<commit_message>
PowerPoint con gráficos nativos editables
Reemplaza las imágenes de los gráficos por objetos de gráfico nativos de
PowerPoint (editables): obsolescencia (columnas apiladas), resultado por
área (combo columnas apiladas + línea de capital en eje secundario) y
aporte sobre el capital (líneas).

Co-Authored-By: Claude Opus 4.8 <noreply@anthropic.com>
Claude-Session: https://claude.ai/code/session_01VpjD3E22CD6nMXHPze7yz4
</commit_message>
<xml_diff>
--- a/Analisis_Capital_de_Trabajo_Autocity.pptx
+++ b/Analisis_Capital_de_Trabajo_Autocity.pptx
@@ -109,6 +109,1374 @@
     </a:lvl9pPr>
   </p:defaultTextStyle>
 </p:presentation>
+</file>
+
+<file path=ppt/charts/chart1.xml><?xml version="1.0" encoding="utf-8"?>
+<c:chartSpace xmlns:c="http://schemas.openxmlformats.org/drawingml/2006/chart" xmlns:a="http://schemas.openxmlformats.org/drawingml/2006/main" xmlns:r="http://schemas.openxmlformats.org/officeDocument/2006/relationships">
+  <c:date1904 val="0"/>
+  <c:chart>
+    <c:autoTitleDeleted val="1"/>
+    <c:plotArea>
+      <c:barChart>
+        <c:barDir val="col"/>
+        <c:grouping val="stacked"/>
+        <c:ser>
+          <c:idx val="0"/>
+          <c:order val="0"/>
+          <c:tx>
+            <c:strRef>
+              <c:f>Sheet1!$B$1</c:f>
+              <c:strCache>
+                <c:ptCount val="1"/>
+                <c:pt idx="0">
+                  <c:v>Rotación + trim. (sano)</c:v>
+                </c:pt>
+              </c:strCache>
+            </c:strRef>
+          </c:tx>
+          <c:spPr>
+            <a:solidFill>
+              <a:srgbClr val="3F8F6A"/>
+            </a:solidFill>
+            <a:ln>
+              <a:noFill/>
+            </a:ln>
+          </c:spPr>
+          <c:cat>
+            <c:strRef>
+              <c:f>Sheet1!$A$2:$A$12</c:f>
+              <c:strCache>
+                <c:ptCount val="11"/>
+                <c:pt idx="0">
+                  <c:v>ene '26</c:v>
+                </c:pt>
+                <c:pt idx="1">
+                  <c:v>feb '26</c:v>
+                </c:pt>
+                <c:pt idx="2">
+                  <c:v>mar '26</c:v>
+                </c:pt>
+                <c:pt idx="3">
+                  <c:v>abr '26</c:v>
+                </c:pt>
+                <c:pt idx="4">
+                  <c:v>may '26</c:v>
+                </c:pt>
+                <c:pt idx="5">
+                  <c:v>jun '26</c:v>
+                </c:pt>
+                <c:pt idx="6">
+                  <c:v>jul '26</c:v>
+                </c:pt>
+                <c:pt idx="7">
+                  <c:v>ago '26</c:v>
+                </c:pt>
+                <c:pt idx="8">
+                  <c:v>sep '26</c:v>
+                </c:pt>
+                <c:pt idx="9">
+                  <c:v>oct '26</c:v>
+                </c:pt>
+                <c:pt idx="10">
+                  <c:v>Objetivo 2027</c:v>
+                </c:pt>
+              </c:strCache>
+            </c:strRef>
+          </c:cat>
+          <c:val>
+            <c:numRef>
+              <c:f>Sheet1!$B$2:$B$12</c:f>
+              <c:numCache>
+                <c:formatCode>General</c:formatCode>
+                <c:ptCount val="11"/>
+                <c:pt idx="0">
+                  <c:v>6388</c:v>
+                </c:pt>
+                <c:pt idx="1">
+                  <c:v>6643</c:v>
+                </c:pt>
+                <c:pt idx="2">
+                  <c:v>7282</c:v>
+                </c:pt>
+                <c:pt idx="3">
+                  <c:v>7591</c:v>
+                </c:pt>
+                <c:pt idx="4">
+                  <c:v>8478</c:v>
+                </c:pt>
+                <c:pt idx="5">
+                  <c:v>8052</c:v>
+                </c:pt>
+                <c:pt idx="6">
+                  <c:v>8533</c:v>
+                </c:pt>
+                <c:pt idx="7">
+                  <c:v>8676</c:v>
+                </c:pt>
+                <c:pt idx="8">
+                  <c:v>8165</c:v>
+                </c:pt>
+                <c:pt idx="9">
+                  <c:v>8030</c:v>
+                </c:pt>
+                <c:pt idx="10">
+                  <c:v>9968</c:v>
+                </c:pt>
+              </c:numCache>
+            </c:numRef>
+          </c:val>
+        </c:ser>
+        <c:ser>
+          <c:idx val="1"/>
+          <c:order val="1"/>
+          <c:tx>
+            <c:strRef>
+              <c:f>Sheet1!$C$1</c:f>
+              <c:strCache>
+                <c:ptCount val="1"/>
+                <c:pt idx="0">
+                  <c:v>Sobrestock semestral</c:v>
+                </c:pt>
+              </c:strCache>
+            </c:strRef>
+          </c:tx>
+          <c:spPr>
+            <a:solidFill>
+              <a:srgbClr val="8A7530"/>
+            </a:solidFill>
+            <a:ln>
+              <a:noFill/>
+            </a:ln>
+          </c:spPr>
+          <c:cat>
+            <c:strRef>
+              <c:f>Sheet1!$A$2:$A$12</c:f>
+              <c:strCache>
+                <c:ptCount val="11"/>
+                <c:pt idx="0">
+                  <c:v>ene '26</c:v>
+                </c:pt>
+                <c:pt idx="1">
+                  <c:v>feb '26</c:v>
+                </c:pt>
+                <c:pt idx="2">
+                  <c:v>mar '26</c:v>
+                </c:pt>
+                <c:pt idx="3">
+                  <c:v>abr '26</c:v>
+                </c:pt>
+                <c:pt idx="4">
+                  <c:v>may '26</c:v>
+                </c:pt>
+                <c:pt idx="5">
+                  <c:v>jun '26</c:v>
+                </c:pt>
+                <c:pt idx="6">
+                  <c:v>jul '26</c:v>
+                </c:pt>
+                <c:pt idx="7">
+                  <c:v>ago '26</c:v>
+                </c:pt>
+                <c:pt idx="8">
+                  <c:v>sep '26</c:v>
+                </c:pt>
+                <c:pt idx="9">
+                  <c:v>oct '26</c:v>
+                </c:pt>
+                <c:pt idx="10">
+                  <c:v>Objetivo 2027</c:v>
+                </c:pt>
+              </c:strCache>
+            </c:strRef>
+          </c:cat>
+          <c:val>
+            <c:numRef>
+              <c:f>Sheet1!$C$2:$C$12</c:f>
+              <c:numCache>
+                <c:formatCode>General</c:formatCode>
+                <c:ptCount val="11"/>
+                <c:pt idx="0">
+                  <c:v>1987</c:v>
+                </c:pt>
+                <c:pt idx="1">
+                  <c:v>2190</c:v>
+                </c:pt>
+                <c:pt idx="2">
+                  <c:v>2204</c:v>
+                </c:pt>
+                <c:pt idx="3">
+                  <c:v>2478</c:v>
+                </c:pt>
+                <c:pt idx="4">
+                  <c:v>2009</c:v>
+                </c:pt>
+                <c:pt idx="5">
+                  <c:v>2198</c:v>
+                </c:pt>
+                <c:pt idx="6">
+                  <c:v>2047</c:v>
+                </c:pt>
+                <c:pt idx="7">
+                  <c:v>1848</c:v>
+                </c:pt>
+                <c:pt idx="8">
+                  <c:v>1978</c:v>
+                </c:pt>
+                <c:pt idx="9">
+                  <c:v>2760</c:v>
+                </c:pt>
+                <c:pt idx="10">
+                  <c:v>1216</c:v>
+                </c:pt>
+              </c:numCache>
+            </c:numRef>
+          </c:val>
+        </c:ser>
+        <c:ser>
+          <c:idx val="2"/>
+          <c:order val="2"/>
+          <c:tx>
+            <c:strRef>
+              <c:f>Sheet1!$D$1</c:f>
+              <c:strCache>
+                <c:ptCount val="1"/>
+                <c:pt idx="0">
+                  <c:v>Obsoleto (muerto + dormido)</c:v>
+                </c:pt>
+              </c:strCache>
+            </c:strRef>
+          </c:tx>
+          <c:spPr>
+            <a:solidFill>
+              <a:srgbClr val="C04343"/>
+            </a:solidFill>
+            <a:ln>
+              <a:noFill/>
+            </a:ln>
+          </c:spPr>
+          <c:cat>
+            <c:strRef>
+              <c:f>Sheet1!$A$2:$A$12</c:f>
+              <c:strCache>
+                <c:ptCount val="11"/>
+                <c:pt idx="0">
+                  <c:v>ene '26</c:v>
+                </c:pt>
+                <c:pt idx="1">
+                  <c:v>feb '26</c:v>
+                </c:pt>
+                <c:pt idx="2">
+                  <c:v>mar '26</c:v>
+                </c:pt>
+                <c:pt idx="3">
+                  <c:v>abr '26</c:v>
+                </c:pt>
+                <c:pt idx="4">
+                  <c:v>may '26</c:v>
+                </c:pt>
+                <c:pt idx="5">
+                  <c:v>jun '26</c:v>
+                </c:pt>
+                <c:pt idx="6">
+                  <c:v>jul '26</c:v>
+                </c:pt>
+                <c:pt idx="7">
+                  <c:v>ago '26</c:v>
+                </c:pt>
+                <c:pt idx="8">
+                  <c:v>sep '26</c:v>
+                </c:pt>
+                <c:pt idx="9">
+                  <c:v>oct '26</c:v>
+                </c:pt>
+                <c:pt idx="10">
+                  <c:v>Objetivo 2027</c:v>
+                </c:pt>
+              </c:strCache>
+            </c:strRef>
+          </c:cat>
+          <c:val>
+            <c:numRef>
+              <c:f>Sheet1!$D$2:$D$12</c:f>
+              <c:numCache>
+                <c:formatCode>General</c:formatCode>
+                <c:ptCount val="11"/>
+                <c:pt idx="0">
+                  <c:v>881</c:v>
+                </c:pt>
+                <c:pt idx="1">
+                  <c:v>878</c:v>
+                </c:pt>
+                <c:pt idx="2">
+                  <c:v>907</c:v>
+                </c:pt>
+                <c:pt idx="3">
+                  <c:v>953</c:v>
+                </c:pt>
+                <c:pt idx="4">
+                  <c:v>1005</c:v>
+                </c:pt>
+                <c:pt idx="5">
+                  <c:v>880</c:v>
+                </c:pt>
+                <c:pt idx="6">
+                  <c:v>921</c:v>
+                </c:pt>
+                <c:pt idx="7">
+                  <c:v>942</c:v>
+                </c:pt>
+                <c:pt idx="8">
+                  <c:v>1367</c:v>
+                </c:pt>
+                <c:pt idx="9">
+                  <c:v>1354</c:v>
+                </c:pt>
+                <c:pt idx="10">
+                  <c:v>972</c:v>
+                </c:pt>
+              </c:numCache>
+            </c:numRef>
+          </c:val>
+        </c:ser>
+        <c:overlap val="100"/>
+        <c:axId val="-2068027336"/>
+        <c:axId val="-2113994440"/>
+      </c:barChart>
+      <c:catAx>
+        <c:axId val="-2068027336"/>
+        <c:scaling>
+          <c:orientation val="minMax"/>
+        </c:scaling>
+        <c:delete val="0"/>
+        <c:axPos val="b"/>
+        <c:majorTickMark val="out"/>
+        <c:minorTickMark val="none"/>
+        <c:tickLblPos val="nextTo"/>
+        <c:txPr>
+          <a:bodyPr/>
+          <a:lstStyle/>
+          <a:p>
+            <a:pPr>
+              <a:defRPr sz="900">
+                <a:latin typeface="Calibri"/>
+              </a:defRPr>
+            </a:pPr>
+          </a:p>
+        </c:txPr>
+        <c:crossAx val="-2113994440"/>
+        <c:crosses val="autoZero"/>
+        <c:auto val="1"/>
+        <c:lblAlgn val="ctr"/>
+        <c:lblOffset val="100"/>
+        <c:noMultiLvlLbl val="0"/>
+      </c:catAx>
+      <c:valAx>
+        <c:axId val="-2113994440"/>
+        <c:scaling/>
+        <c:delete val="0"/>
+        <c:axPos val="l"/>
+        <c:majorGridlines/>
+        <c:majorTickMark val="out"/>
+        <c:minorTickMark val="none"/>
+        <c:tickLblPos val="nextTo"/>
+        <c:txPr>
+          <a:bodyPr/>
+          <a:lstStyle/>
+          <a:p>
+            <a:pPr>
+              <a:defRPr sz="900">
+                <a:latin typeface="Calibri"/>
+              </a:defRPr>
+            </a:pPr>
+          </a:p>
+        </c:txPr>
+        <c:crossAx val="-2068027336"/>
+        <c:crosses val="autoZero"/>
+      </c:valAx>
+    </c:plotArea>
+    <c:legend>
+      <c:legendPos val="t"/>
+      <c:overlay val="0"/>
+      <c:txPr>
+        <a:bodyPr/>
+        <a:lstStyle/>
+        <a:p>
+          <a:pPr>
+            <a:defRPr sz="1000">
+              <a:latin typeface="Calibri"/>
+            </a:defRPr>
+          </a:pPr>
+        </a:p>
+      </c:txPr>
+    </c:legend>
+    <c:dispBlanksAs val="gap"/>
+  </c:chart>
+  <c:txPr>
+    <a:bodyPr/>
+    <a:lstStyle/>
+    <a:p>
+      <a:pPr>
+        <a:defRPr sz="1800"/>
+      </a:pPr>
+      <a:endParaRPr lang="en-US"/>
+    </a:p>
+  </c:txPr>
+  <c:externalData r:id="rId1">
+    <c:autoUpdate val="0"/>
+  </c:externalData>
+</c:chartSpace>
+</file>
+
+<file path=ppt/charts/chart2.xml><?xml version="1.0" encoding="utf-8"?>
+<c:chartSpace xmlns:c="http://schemas.openxmlformats.org/drawingml/2006/chart" xmlns:a="http://schemas.openxmlformats.org/drawingml/2006/main" xmlns:r="http://schemas.openxmlformats.org/officeDocument/2006/relationships">
+  <c:date1904 val="0"/>
+  <c:chart>
+    <c:autoTitleDeleted val="1"/>
+    <c:plotArea>
+      <c:barChart>
+        <c:barDir val="col"/>
+        <c:grouping val="stacked"/>
+        <c:ser>
+          <c:idx val="0"/>
+          <c:order val="0"/>
+          <c:tx>
+            <c:strRef>
+              <c:f>Sheet1!$B$1</c:f>
+              <c:strCache>
+                <c:ptCount val="1"/>
+                <c:pt idx="0">
+                  <c:v>Bienes (rep + accesorios)</c:v>
+                </c:pt>
+              </c:strCache>
+            </c:strRef>
+          </c:tx>
+          <c:spPr>
+            <a:solidFill>
+              <a:srgbClr val="2F6690"/>
+            </a:solidFill>
+            <a:ln>
+              <a:noFill/>
+            </a:ln>
+          </c:spPr>
+          <c:cat>
+            <c:strRef>
+              <c:f>Sheet1!$A$2:$A$9</c:f>
+              <c:strCache>
+                <c:ptCount val="8"/>
+                <c:pt idx="0">
+                  <c:v>ene '26</c:v>
+                </c:pt>
+                <c:pt idx="1">
+                  <c:v>feb '26</c:v>
+                </c:pt>
+                <c:pt idx="2">
+                  <c:v>mar '26</c:v>
+                </c:pt>
+                <c:pt idx="3">
+                  <c:v>abr '26</c:v>
+                </c:pt>
+                <c:pt idx="4">
+                  <c:v>may '26</c:v>
+                </c:pt>
+                <c:pt idx="5">
+                  <c:v>jun '26</c:v>
+                </c:pt>
+                <c:pt idx="6">
+                  <c:v>jul '26</c:v>
+                </c:pt>
+                <c:pt idx="7">
+                  <c:v>ago '26</c:v>
+                </c:pt>
+              </c:strCache>
+            </c:strRef>
+          </c:cat>
+          <c:val>
+            <c:numRef>
+              <c:f>Sheet1!$B$2:$B$9</c:f>
+              <c:numCache>
+                <c:formatCode>General</c:formatCode>
+                <c:ptCount val="8"/>
+                <c:pt idx="0">
+                  <c:v>242</c:v>
+                </c:pt>
+                <c:pt idx="1">
+                  <c:v>79</c:v>
+                </c:pt>
+                <c:pt idx="2">
+                  <c:v>334</c:v>
+                </c:pt>
+                <c:pt idx="3">
+                  <c:v>306</c:v>
+                </c:pt>
+                <c:pt idx="4">
+                  <c:v>123</c:v>
+                </c:pt>
+                <c:pt idx="5">
+                  <c:v>287</c:v>
+                </c:pt>
+                <c:pt idx="6">
+                  <c:v>308</c:v>
+                </c:pt>
+                <c:pt idx="7">
+                  <c:v>296</c:v>
+                </c:pt>
+              </c:numCache>
+            </c:numRef>
+          </c:val>
+        </c:ser>
+        <c:ser>
+          <c:idx val="1"/>
+          <c:order val="1"/>
+          <c:tx>
+            <c:strRef>
+              <c:f>Sheet1!$C$1</c:f>
+              <c:strCache>
+                <c:ptCount val="1"/>
+                <c:pt idx="0">
+                  <c:v>Servicios (taller + siniestros)</c:v>
+                </c:pt>
+              </c:strCache>
+            </c:strRef>
+          </c:tx>
+          <c:spPr>
+            <a:solidFill>
+              <a:srgbClr val="3F8F6A"/>
+            </a:solidFill>
+            <a:ln>
+              <a:noFill/>
+            </a:ln>
+          </c:spPr>
+          <c:cat>
+            <c:strRef>
+              <c:f>Sheet1!$A$2:$A$9</c:f>
+              <c:strCache>
+                <c:ptCount val="8"/>
+                <c:pt idx="0">
+                  <c:v>ene '26</c:v>
+                </c:pt>
+                <c:pt idx="1">
+                  <c:v>feb '26</c:v>
+                </c:pt>
+                <c:pt idx="2">
+                  <c:v>mar '26</c:v>
+                </c:pt>
+                <c:pt idx="3">
+                  <c:v>abr '26</c:v>
+                </c:pt>
+                <c:pt idx="4">
+                  <c:v>may '26</c:v>
+                </c:pt>
+                <c:pt idx="5">
+                  <c:v>jun '26</c:v>
+                </c:pt>
+                <c:pt idx="6">
+                  <c:v>jul '26</c:v>
+                </c:pt>
+                <c:pt idx="7">
+                  <c:v>ago '26</c:v>
+                </c:pt>
+              </c:strCache>
+            </c:strRef>
+          </c:cat>
+          <c:val>
+            <c:numRef>
+              <c:f>Sheet1!$C$2:$C$9</c:f>
+              <c:numCache>
+                <c:formatCode>General</c:formatCode>
+                <c:ptCount val="8"/>
+                <c:pt idx="0">
+                  <c:v>175</c:v>
+                </c:pt>
+                <c:pt idx="1">
+                  <c:v>32</c:v>
+                </c:pt>
+                <c:pt idx="2">
+                  <c:v>323</c:v>
+                </c:pt>
+                <c:pt idx="3">
+                  <c:v>319</c:v>
+                </c:pt>
+                <c:pt idx="4">
+                  <c:v>203</c:v>
+                </c:pt>
+                <c:pt idx="5">
+                  <c:v>263</c:v>
+                </c:pt>
+                <c:pt idx="6">
+                  <c:v>359</c:v>
+                </c:pt>
+                <c:pt idx="7">
+                  <c:v>408</c:v>
+                </c:pt>
+              </c:numCache>
+            </c:numRef>
+          </c:val>
+        </c:ser>
+        <c:ser>
+          <c:idx val="2"/>
+          <c:order val="2"/>
+          <c:tx>
+            <c:strRef>
+              <c:f>Sheet1!$D$1</c:f>
+              <c:strCache>
+                <c:ptCount val="1"/>
+                <c:pt idx="0">
+                  <c:v>Resultados de stock</c:v>
+                </c:pt>
+              </c:strCache>
+            </c:strRef>
+          </c:tx>
+          <c:spPr>
+            <a:solidFill>
+              <a:srgbClr val="8A7530"/>
+            </a:solidFill>
+            <a:ln>
+              <a:noFill/>
+            </a:ln>
+          </c:spPr>
+          <c:cat>
+            <c:strRef>
+              <c:f>Sheet1!$A$2:$A$9</c:f>
+              <c:strCache>
+                <c:ptCount val="8"/>
+                <c:pt idx="0">
+                  <c:v>ene '26</c:v>
+                </c:pt>
+                <c:pt idx="1">
+                  <c:v>feb '26</c:v>
+                </c:pt>
+                <c:pt idx="2">
+                  <c:v>mar '26</c:v>
+                </c:pt>
+                <c:pt idx="3">
+                  <c:v>abr '26</c:v>
+                </c:pt>
+                <c:pt idx="4">
+                  <c:v>may '26</c:v>
+                </c:pt>
+                <c:pt idx="5">
+                  <c:v>jun '26</c:v>
+                </c:pt>
+                <c:pt idx="6">
+                  <c:v>jul '26</c:v>
+                </c:pt>
+                <c:pt idx="7">
+                  <c:v>ago '26</c:v>
+                </c:pt>
+              </c:strCache>
+            </c:strRef>
+          </c:cat>
+          <c:val>
+            <c:numRef>
+              <c:f>Sheet1!$D$2:$D$9</c:f>
+              <c:numCache>
+                <c:formatCode>General</c:formatCode>
+                <c:ptCount val="8"/>
+                <c:pt idx="0">
+                  <c:v>176</c:v>
+                </c:pt>
+                <c:pt idx="1">
+                  <c:v>228</c:v>
+                </c:pt>
+                <c:pt idx="2">
+                  <c:v>317</c:v>
+                </c:pt>
+                <c:pt idx="3">
+                  <c:v>131</c:v>
+                </c:pt>
+                <c:pt idx="4">
+                  <c:v>260</c:v>
+                </c:pt>
+                <c:pt idx="5">
+                  <c:v>36</c:v>
+                </c:pt>
+                <c:pt idx="6">
+                  <c:v>267</c:v>
+                </c:pt>
+                <c:pt idx="7">
+                  <c:v>-218</c:v>
+                </c:pt>
+              </c:numCache>
+            </c:numRef>
+          </c:val>
+        </c:ser>
+        <c:overlap val="100"/>
+        <c:axId val="-2068027336"/>
+        <c:axId val="-2113994440"/>
+      </c:barChart>
+      <c:lineChart>
+        <c:grouping val="standard"/>
+        <c:varyColors val="0"/>
+        <c:ser>
+          <c:idx val="9"/>
+          <c:order val="9"/>
+          <c:tx>
+            <c:strRef>
+              <c:f>Sheet1!$Z$1</c:f>
+              <c:strCache>
+                <c:ptCount val="1"/>
+                <c:pt idx="0">
+                  <c:v>Capital de trabajo (total)</c:v>
+                </c:pt>
+              </c:strCache>
+            </c:strRef>
+          </c:tx>
+          <c:spPr>
+            <a:ln w="31750">
+              <a:solidFill>
+                <a:srgbClr val="1a1f27"/>
+              </a:solidFill>
+            </a:ln>
+          </c:spPr>
+          <c:marker>
+            <c:symbol val="circle"/>
+            <c:size val="5"/>
+            <c:spPr>
+              <a:solidFill>
+                <a:srgbClr val="1a1f27"/>
+              </a:solidFill>
+              <a:ln>
+                <a:solidFill>
+                  <a:srgbClr val="1a1f27"/>
+                </a:solidFill>
+              </a:ln>
+            </c:spPr>
+          </c:marker>
+          <c:cat>
+            <c:strRef>
+              <c:f>Sheet1!$A$2:$A$9</c:f>
+              <c:strCache>
+                <c:ptCount val="8"/>
+                <c:pt idx="0">
+                  <c:v>ene '26</c:v>
+                </c:pt>
+                <c:pt idx="1">
+                  <c:v>feb '26</c:v>
+                </c:pt>
+                <c:pt idx="2">
+                  <c:v>mar '26</c:v>
+                </c:pt>
+                <c:pt idx="3">
+                  <c:v>abr '26</c:v>
+                </c:pt>
+                <c:pt idx="4">
+                  <c:v>may '26</c:v>
+                </c:pt>
+                <c:pt idx="5">
+                  <c:v>jun '26</c:v>
+                </c:pt>
+                <c:pt idx="6">
+                  <c:v>jul '26</c:v>
+                </c:pt>
+                <c:pt idx="7">
+                  <c:v>ago '26</c:v>
+                </c:pt>
+              </c:strCache>
+            </c:strRef>
+          </c:cat>
+          <c:val>
+            <c:numRef>
+              <c:f>Sheet1!$Z$2:$Z$9</c:f>
+              <c:numCache>
+                <c:formatCode>General</c:formatCode>
+                <c:ptCount val="8"/>
+                <c:pt idx="0">
+                  <c:v>9769</c:v>
+                </c:pt>
+                <c:pt idx="1">
+                  <c:v>10124</c:v>
+                </c:pt>
+                <c:pt idx="2">
+                  <c:v>10479</c:v>
+                </c:pt>
+                <c:pt idx="3">
+                  <c:v>11189</c:v>
+                </c:pt>
+                <c:pt idx="4">
+                  <c:v>11995</c:v>
+                </c:pt>
+                <c:pt idx="5">
+                  <c:v>12687</c:v>
+                </c:pt>
+                <c:pt idx="6">
+                  <c:v>12367</c:v>
+                </c:pt>
+                <c:pt idx="7">
+                  <c:v>13962</c:v>
+                </c:pt>
+              </c:numCache>
+            </c:numRef>
+          </c:val>
+          <c:smooth val="0"/>
+        </c:ser>
+        <c:marker val="1"/>
+        <c:axId val="800"/>
+        <c:axId val="900"/>
+      </c:lineChart>
+      <c:catAx>
+        <c:axId val="-2068027336"/>
+        <c:scaling>
+          <c:orientation val="minMax"/>
+        </c:scaling>
+        <c:delete val="0"/>
+        <c:axPos val="b"/>
+        <c:majorTickMark val="out"/>
+        <c:minorTickMark val="none"/>
+        <c:tickLblPos val="nextTo"/>
+        <c:txPr>
+          <a:bodyPr/>
+          <a:lstStyle/>
+          <a:p>
+            <a:pPr>
+              <a:defRPr sz="900">
+                <a:latin typeface="Calibri"/>
+              </a:defRPr>
+            </a:pPr>
+          </a:p>
+        </c:txPr>
+        <c:crossAx val="-2113994440"/>
+        <c:crosses val="autoZero"/>
+        <c:auto val="1"/>
+        <c:lblAlgn val="ctr"/>
+        <c:lblOffset val="100"/>
+        <c:noMultiLvlLbl val="0"/>
+      </c:catAx>
+      <c:valAx>
+        <c:axId val="-2113994440"/>
+        <c:scaling/>
+        <c:delete val="0"/>
+        <c:axPos val="l"/>
+        <c:majorGridlines/>
+        <c:majorTickMark val="out"/>
+        <c:minorTickMark val="none"/>
+        <c:tickLblPos val="nextTo"/>
+        <c:txPr>
+          <a:bodyPr/>
+          <a:lstStyle/>
+          <a:p>
+            <a:pPr>
+              <a:defRPr sz="900">
+                <a:latin typeface="Calibri"/>
+              </a:defRPr>
+            </a:pPr>
+          </a:p>
+        </c:txPr>
+        <c:crossAx val="-2068027336"/>
+        <c:crosses val="autoZero"/>
+      </c:valAx>
+      <c:catAx>
+        <c:axId val="800"/>
+        <c:scaling>
+          <c:orientation val="minMax"/>
+        </c:scaling>
+        <c:delete val="1"/>
+        <c:axPos val="b"/>
+        <c:majorTickMark val="none"/>
+        <c:minorTickMark val="none"/>
+        <c:tickLblPos val="none"/>
+        <c:crossAx val="900"/>
+      </c:catAx>
+      <c:valAx>
+        <c:axId val="900"/>
+        <c:scaling>
+          <c:orientation val="minMax"/>
+        </c:scaling>
+        <c:delete val="0"/>
+        <c:axPos val="r"/>
+        <c:numFmt formatCode="&quot;$&quot;#,##0" sourceLinked="0"/>
+        <c:majorTickMark val="out"/>
+        <c:minorTickMark val="none"/>
+        <c:tickLblPos val="nextTo"/>
+        <c:crossAx val="800"/>
+        <c:crosses val="max"/>
+      </c:valAx>
+    </c:plotArea>
+    <c:legend>
+      <c:legendPos val="t"/>
+      <c:overlay val="0"/>
+      <c:txPr>
+        <a:bodyPr/>
+        <a:lstStyle/>
+        <a:p>
+          <a:pPr>
+            <a:defRPr sz="1000">
+              <a:latin typeface="Calibri"/>
+            </a:defRPr>
+          </a:pPr>
+        </a:p>
+      </c:txPr>
+    </c:legend>
+    <c:dispBlanksAs val="gap"/>
+  </c:chart>
+  <c:txPr>
+    <a:bodyPr/>
+    <a:lstStyle/>
+    <a:p>
+      <a:pPr>
+        <a:defRPr sz="1800"/>
+      </a:pPr>
+      <a:endParaRPr lang="en-US"/>
+    </a:p>
+  </c:txPr>
+  <c:externalData r:id="rId1">
+    <c:autoUpdate val="0"/>
+  </c:externalData>
+</c:chartSpace>
+</file>
+
+<file path=ppt/charts/chart3.xml><?xml version="1.0" encoding="utf-8"?>
+<c:chartSpace xmlns:c="http://schemas.openxmlformats.org/drawingml/2006/chart" xmlns:a="http://schemas.openxmlformats.org/drawingml/2006/main" xmlns:r="http://schemas.openxmlformats.org/officeDocument/2006/relationships">
+  <c:date1904 val="0"/>
+  <c:chart>
+    <c:autoTitleDeleted val="1"/>
+    <c:plotArea>
+      <c:lineChart>
+        <c:grouping val="standard"/>
+        <c:varyColors val="0"/>
+        <c:ser>
+          <c:idx val="0"/>
+          <c:order val="0"/>
+          <c:tx>
+            <c:strRef>
+              <c:f>Sheet1!$B$1</c:f>
+              <c:strCache>
+                <c:ptCount val="1"/>
+                <c:pt idx="0">
+                  <c:v>Bienes</c:v>
+                </c:pt>
+              </c:strCache>
+            </c:strRef>
+          </c:tx>
+          <c:spPr>
+            <a:ln w="25400">
+              <a:solidFill>
+                <a:srgbClr val="2F6690"/>
+              </a:solidFill>
+            </a:ln>
+          </c:spPr>
+          <c:cat>
+            <c:strRef>
+              <c:f>Sheet1!$A$2:$A$9</c:f>
+              <c:strCache>
+                <c:ptCount val="8"/>
+                <c:pt idx="0">
+                  <c:v>ene '26</c:v>
+                </c:pt>
+                <c:pt idx="1">
+                  <c:v>feb '26</c:v>
+                </c:pt>
+                <c:pt idx="2">
+                  <c:v>mar '26</c:v>
+                </c:pt>
+                <c:pt idx="3">
+                  <c:v>abr '26</c:v>
+                </c:pt>
+                <c:pt idx="4">
+                  <c:v>may '26</c:v>
+                </c:pt>
+                <c:pt idx="5">
+                  <c:v>jun '26</c:v>
+                </c:pt>
+                <c:pt idx="6">
+                  <c:v>jul '26</c:v>
+                </c:pt>
+                <c:pt idx="7">
+                  <c:v>ago '26</c:v>
+                </c:pt>
+              </c:strCache>
+            </c:strRef>
+          </c:cat>
+          <c:val>
+            <c:numRef>
+              <c:f>Sheet1!$B$2:$B$9</c:f>
+              <c:numCache>
+                <c:formatCode>General</c:formatCode>
+                <c:ptCount val="8"/>
+                <c:pt idx="0">
+                  <c:v>2.48</c:v>
+                </c:pt>
+                <c:pt idx="1">
+                  <c:v>0.78</c:v>
+                </c:pt>
+                <c:pt idx="2">
+                  <c:v>3.19</c:v>
+                </c:pt>
+                <c:pt idx="3">
+                  <c:v>2.73</c:v>
+                </c:pt>
+                <c:pt idx="4">
+                  <c:v>1.03</c:v>
+                </c:pt>
+                <c:pt idx="5">
+                  <c:v>2.26</c:v>
+                </c:pt>
+                <c:pt idx="6">
+                  <c:v>2.49</c:v>
+                </c:pt>
+                <c:pt idx="7">
+                  <c:v>2.12</c:v>
+                </c:pt>
+              </c:numCache>
+            </c:numRef>
+          </c:val>
+          <c:smooth val="0"/>
+        </c:ser>
+        <c:ser>
+          <c:idx val="1"/>
+          <c:order val="1"/>
+          <c:tx>
+            <c:strRef>
+              <c:f>Sheet1!$C$1</c:f>
+              <c:strCache>
+                <c:ptCount val="1"/>
+                <c:pt idx="0">
+                  <c:v>Servicios</c:v>
+                </c:pt>
+              </c:strCache>
+            </c:strRef>
+          </c:tx>
+          <c:spPr>
+            <a:ln w="25400">
+              <a:solidFill>
+                <a:srgbClr val="3F8F6A"/>
+              </a:solidFill>
+            </a:ln>
+          </c:spPr>
+          <c:cat>
+            <c:strRef>
+              <c:f>Sheet1!$A$2:$A$9</c:f>
+              <c:strCache>
+                <c:ptCount val="8"/>
+                <c:pt idx="0">
+                  <c:v>ene '26</c:v>
+                </c:pt>
+                <c:pt idx="1">
+                  <c:v>feb '26</c:v>
+                </c:pt>
+                <c:pt idx="2">
+                  <c:v>mar '26</c:v>
+                </c:pt>
+                <c:pt idx="3">
+                  <c:v>abr '26</c:v>
+                </c:pt>
+                <c:pt idx="4">
+                  <c:v>may '26</c:v>
+                </c:pt>
+                <c:pt idx="5">
+                  <c:v>jun '26</c:v>
+                </c:pt>
+                <c:pt idx="6">
+                  <c:v>jul '26</c:v>
+                </c:pt>
+                <c:pt idx="7">
+                  <c:v>ago '26</c:v>
+                </c:pt>
+              </c:strCache>
+            </c:strRef>
+          </c:cat>
+          <c:val>
+            <c:numRef>
+              <c:f>Sheet1!$C$2:$C$9</c:f>
+              <c:numCache>
+                <c:formatCode>General</c:formatCode>
+                <c:ptCount val="8"/>
+                <c:pt idx="0">
+                  <c:v>1.79</c:v>
+                </c:pt>
+                <c:pt idx="1">
+                  <c:v>0.32</c:v>
+                </c:pt>
+                <c:pt idx="2">
+                  <c:v>3.08</c:v>
+                </c:pt>
+                <c:pt idx="3">
+                  <c:v>2.85</c:v>
+                </c:pt>
+                <c:pt idx="4">
+                  <c:v>1.69</c:v>
+                </c:pt>
+                <c:pt idx="5">
+                  <c:v>2.07</c:v>
+                </c:pt>
+                <c:pt idx="6">
+                  <c:v>2.9</c:v>
+                </c:pt>
+                <c:pt idx="7">
+                  <c:v>2.92</c:v>
+                </c:pt>
+              </c:numCache>
+            </c:numRef>
+          </c:val>
+          <c:smooth val="0"/>
+        </c:ser>
+        <c:ser>
+          <c:idx val="2"/>
+          <c:order val="2"/>
+          <c:tx>
+            <c:strRef>
+              <c:f>Sheet1!$D$1</c:f>
+              <c:strCache>
+                <c:ptCount val="1"/>
+                <c:pt idx="0">
+                  <c:v>Resultados de stock</c:v>
+                </c:pt>
+              </c:strCache>
+            </c:strRef>
+          </c:tx>
+          <c:spPr>
+            <a:ln w="25400">
+              <a:solidFill>
+                <a:srgbClr val="8A7530"/>
+              </a:solidFill>
+            </a:ln>
+          </c:spPr>
+          <c:cat>
+            <c:strRef>
+              <c:f>Sheet1!$A$2:$A$9</c:f>
+              <c:strCache>
+                <c:ptCount val="8"/>
+                <c:pt idx="0">
+                  <c:v>ene '26</c:v>
+                </c:pt>
+                <c:pt idx="1">
+                  <c:v>feb '26</c:v>
+                </c:pt>
+                <c:pt idx="2">
+                  <c:v>mar '26</c:v>
+                </c:pt>
+                <c:pt idx="3">
+                  <c:v>abr '26</c:v>
+                </c:pt>
+                <c:pt idx="4">
+                  <c:v>may '26</c:v>
+                </c:pt>
+                <c:pt idx="5">
+                  <c:v>jun '26</c:v>
+                </c:pt>
+                <c:pt idx="6">
+                  <c:v>jul '26</c:v>
+                </c:pt>
+                <c:pt idx="7">
+                  <c:v>ago '26</c:v>
+                </c:pt>
+              </c:strCache>
+            </c:strRef>
+          </c:cat>
+          <c:val>
+            <c:numRef>
+              <c:f>Sheet1!$D$2:$D$9</c:f>
+              <c:numCache>
+                <c:formatCode>General</c:formatCode>
+                <c:ptCount val="8"/>
+                <c:pt idx="0">
+                  <c:v>1.8</c:v>
+                </c:pt>
+                <c:pt idx="1">
+                  <c:v>2.25</c:v>
+                </c:pt>
+                <c:pt idx="2">
+                  <c:v>3.03</c:v>
+                </c:pt>
+                <c:pt idx="3">
+                  <c:v>1.17</c:v>
+                </c:pt>
+                <c:pt idx="4">
+                  <c:v>2.17</c:v>
+                </c:pt>
+                <c:pt idx="5">
+                  <c:v>0.28</c:v>
+                </c:pt>
+                <c:pt idx="6">
+                  <c:v>2.16</c:v>
+                </c:pt>
+                <c:pt idx="7">
+                  <c:v>-1.56</c:v>
+                </c:pt>
+              </c:numCache>
+            </c:numRef>
+          </c:val>
+          <c:smooth val="0"/>
+        </c:ser>
+        <c:ser>
+          <c:idx val="3"/>
+          <c:order val="3"/>
+          <c:tx>
+            <c:strRef>
+              <c:f>Sheet1!$E$1</c:f>
+              <c:strCache>
+                <c:ptCount val="1"/>
+                <c:pt idx="0">
+                  <c:v>Total</c:v>
+                </c:pt>
+              </c:strCache>
+            </c:strRef>
+          </c:tx>
+          <c:spPr>
+            <a:ln w="38100">
+              <a:solidFill>
+                <a:srgbClr val="1A1F27"/>
+              </a:solidFill>
+            </a:ln>
+          </c:spPr>
+          <c:cat>
+            <c:strRef>
+              <c:f>Sheet1!$A$2:$A$9</c:f>
+              <c:strCache>
+                <c:ptCount val="8"/>
+                <c:pt idx="0">
+                  <c:v>ene '26</c:v>
+                </c:pt>
+                <c:pt idx="1">
+                  <c:v>feb '26</c:v>
+                </c:pt>
+                <c:pt idx="2">
+                  <c:v>mar '26</c:v>
+                </c:pt>
+                <c:pt idx="3">
+                  <c:v>abr '26</c:v>
+                </c:pt>
+                <c:pt idx="4">
+                  <c:v>may '26</c:v>
+                </c:pt>
+                <c:pt idx="5">
+                  <c:v>jun '26</c:v>
+                </c:pt>
+                <c:pt idx="6">
+                  <c:v>jul '26</c:v>
+                </c:pt>
+                <c:pt idx="7">
+                  <c:v>ago '26</c:v>
+                </c:pt>
+              </c:strCache>
+            </c:strRef>
+          </c:cat>
+          <c:val>
+            <c:numRef>
+              <c:f>Sheet1!$E$2:$E$9</c:f>
+              <c:numCache>
+                <c:formatCode>General</c:formatCode>
+                <c:ptCount val="8"/>
+                <c:pt idx="0">
+                  <c:v>6.07</c:v>
+                </c:pt>
+                <c:pt idx="1">
+                  <c:v>3.35</c:v>
+                </c:pt>
+                <c:pt idx="2">
+                  <c:v>9.29</c:v>
+                </c:pt>
+                <c:pt idx="3">
+                  <c:v>6.76</c:v>
+                </c:pt>
+                <c:pt idx="4">
+                  <c:v>4.89</c:v>
+                </c:pt>
+                <c:pt idx="5">
+                  <c:v>4.62</c:v>
+                </c:pt>
+                <c:pt idx="6">
+                  <c:v>7.55</c:v>
+                </c:pt>
+                <c:pt idx="7">
+                  <c:v>3.48</c:v>
+                </c:pt>
+              </c:numCache>
+            </c:numRef>
+          </c:val>
+          <c:smooth val="0"/>
+        </c:ser>
+        <c:marker val="1"/>
+        <c:smooth val="0"/>
+        <c:axId val="2118791784"/>
+        <c:axId val="2140495176"/>
+      </c:lineChart>
+      <c:catAx>
+        <c:axId val="2118791784"/>
+        <c:scaling>
+          <c:orientation val="minMax"/>
+        </c:scaling>
+        <c:delete val="0"/>
+        <c:axPos val="b"/>
+        <c:majorTickMark val="out"/>
+        <c:minorTickMark val="none"/>
+        <c:tickLblPos val="nextTo"/>
+        <c:txPr>
+          <a:bodyPr/>
+          <a:lstStyle/>
+          <a:p>
+            <a:pPr>
+              <a:defRPr sz="900">
+                <a:latin typeface="Calibri"/>
+              </a:defRPr>
+            </a:pPr>
+          </a:p>
+        </c:txPr>
+        <c:crossAx val="2140495176"/>
+        <c:crosses val="autoZero"/>
+        <c:auto val="1"/>
+        <c:lblAlgn val="ctr"/>
+        <c:lblOffset val="100"/>
+        <c:noMultiLvlLbl val="0"/>
+      </c:catAx>
+      <c:valAx>
+        <c:axId val="2140495176"/>
+        <c:scaling/>
+        <c:delete val="0"/>
+        <c:axPos val="l"/>
+        <c:majorGridlines/>
+        <c:numFmt formatCode="0&quot;%&quot;" sourceLinked="0"/>
+        <c:majorTickMark val="out"/>
+        <c:minorTickMark val="none"/>
+        <c:tickLblPos val="nextTo"/>
+        <c:txPr>
+          <a:bodyPr/>
+          <a:lstStyle/>
+          <a:p>
+            <a:pPr>
+              <a:defRPr sz="900">
+                <a:latin typeface="Calibri"/>
+              </a:defRPr>
+            </a:pPr>
+          </a:p>
+        </c:txPr>
+        <c:crossAx val="2118791784"/>
+        <c:crosses val="autoZero"/>
+      </c:valAx>
+    </c:plotArea>
+    <c:legend>
+      <c:legendPos val="t"/>
+      <c:layout/>
+      <c:overlay val="0"/>
+      <c:txPr>
+        <a:bodyPr/>
+        <a:lstStyle/>
+        <a:p>
+          <a:pPr>
+            <a:defRPr sz="1000">
+              <a:latin typeface="Calibri"/>
+            </a:defRPr>
+          </a:pPr>
+        </a:p>
+      </c:txPr>
+    </c:legend>
+    <c:plotVisOnly val="1"/>
+    <c:dispBlanksAs val="gap"/>
+    <c:showDLblsOverMax val="0"/>
+  </c:chart>
+  <c:txPr>
+    <a:bodyPr/>
+    <a:lstStyle/>
+    <a:p>
+      <a:pPr>
+        <a:defRPr sz="1800"/>
+      </a:pPr>
+      <a:endParaRPr lang="en-US"/>
+    </a:p>
+  </c:txPr>
+  <c:externalData r:id="rId1">
+    <c:autoUpdate val="0"/>
+  </c:externalData>
+</c:chartSpace>
 </file>
 
 <file path=ppt/slideLayouts/slideLayout1.xml><?xml version="1.0" encoding="utf-8"?>
@@ -4224,7 +5592,7 @@
                 </a:solidFill>
                 <a:latin typeface="Calibri"/>
               </a:rPr>
-              <a:t>Autocity · Posventa (repuestos, taller, siniestros, accesorios) · $ millones · fuente: cuadros de resultados y planilla de capital de trabajo</a:t>
+              <a:t>Autocity · Posventa (repuestos, taller, siniestros, accesorios) · $ millones</a:t>
             </a:r>
           </a:p>
         </p:txBody>
@@ -4334,7 +5702,7 @@
               </a:spcAft>
             </a:pPr>
             <a:r>
-              <a:rPr sz="2700" b="1">
+              <a:rPr sz="2600" b="1">
                 <a:solidFill>
                   <a:srgbClr val="1A1F27"/>
                 </a:solidFill>
@@ -4345,30 +5713,24 @@
           </a:p>
         </p:txBody>
       </p:sp>
-      <p:pic>
-        <p:nvPicPr>
-          <p:cNvPr id="4" name="Picture 3" descr="c1.png"/>
-          <p:cNvPicPr>
-            <a:picLocks noChangeAspect="1"/>
-          </p:cNvPicPr>
+      <p:graphicFrame>
+        <p:nvGraphicFramePr>
+          <p:cNvPr id="4" name="Chart 3"/>
+          <p:cNvGraphicFramePr>
+            <a:graphicFrameLocks noGrp="1"/>
+          </p:cNvGraphicFramePr>
           <p:nvPr/>
-        </p:nvPicPr>
-        <p:blipFill>
-          <a:blip r:embed="rId2"/>
-          <a:stretch>
-            <a:fillRect/>
-          </a:stretch>
-        </p:blipFill>
-        <p:spPr>
-          <a:xfrm>
-            <a:off x="968455" y="1417320"/>
-            <a:ext cx="10224608" cy="3383280"/>
-          </a:xfrm>
-          <a:prstGeom prst="rect">
-            <a:avLst/>
-          </a:prstGeom>
-        </p:spPr>
-      </p:pic>
+        </p:nvGraphicFramePr>
+        <p:xfrm>
+          <a:off x="548640" y="1371600"/>
+          <a:ext cx="11064240" cy="3520440"/>
+        </p:xfrm>
+        <a:graphic>
+          <a:graphicData uri="http://schemas.openxmlformats.org/drawingml/2006/chart">
+            <c:chart xmlns:c="http://schemas.openxmlformats.org/drawingml/2006/chart" r:id="rId2"/>
+          </a:graphicData>
+        </a:graphic>
+      </p:graphicFrame>
       <p:sp>
         <p:nvSpPr>
           <p:cNvPr id="5" name="TextBox 4"/>
@@ -4377,8 +5739,8 @@
         </p:nvSpPr>
         <p:spPr>
           <a:xfrm>
-            <a:off x="640080" y="4983480"/>
-            <a:ext cx="10881360" cy="1600199"/>
+            <a:off x="640080" y="5029200"/>
+            <a:ext cx="10881360" cy="1645920"/>
           </a:xfrm>
           <a:prstGeom prst="rect">
             <a:avLst/>
@@ -4396,11 +5758,11 @@
                 <a:spcPct val="105000"/>
               </a:lnSpc>
               <a:spcAft>
-                <a:spcPts val="700"/>
+                <a:spcPts val="600"/>
               </a:spcAft>
             </a:pPr>
             <a:r>
-              <a:rPr sz="1250">
+              <a:rPr sz="1150">
                 <a:solidFill>
                   <a:srgbClr val="2F9E5C"/>
                 </a:solidFill>
@@ -4409,7 +5771,7 @@
               <a:t>■  </a:t>
             </a:r>
             <a:r>
-              <a:rPr sz="1250">
+              <a:rPr sz="1150">
                 <a:solidFill>
                   <a:srgbClr val="1A1F27"/>
                 </a:solidFill>
@@ -4424,11 +5786,11 @@
                 <a:spcPct val="105000"/>
               </a:lnSpc>
               <a:spcAft>
-                <a:spcPts val="700"/>
+                <a:spcPts val="600"/>
               </a:spcAft>
             </a:pPr>
             <a:r>
-              <a:rPr sz="1250">
+              <a:rPr sz="1150">
                 <a:solidFill>
                   <a:srgbClr val="C04343"/>
                 </a:solidFill>
@@ -4437,7 +5799,7 @@
               <a:t>■  </a:t>
             </a:r>
             <a:r>
-              <a:rPr sz="1250">
+              <a:rPr sz="1150">
                 <a:solidFill>
                   <a:srgbClr val="1A1F27"/>
                 </a:solidFill>
@@ -4452,11 +5814,11 @@
                 <a:spcPct val="105000"/>
               </a:lnSpc>
               <a:spcAft>
-                <a:spcPts val="700"/>
+                <a:spcPts val="600"/>
               </a:spcAft>
             </a:pPr>
             <a:r>
-              <a:rPr sz="1250">
+              <a:rPr sz="1150">
                 <a:solidFill>
                   <a:srgbClr val="C04343"/>
                 </a:solidFill>
@@ -4465,7 +5827,7 @@
               <a:t>■  </a:t>
             </a:r>
             <a:r>
-              <a:rPr sz="1250">
+              <a:rPr sz="1150">
                 <a:solidFill>
                   <a:srgbClr val="1A1F27"/>
                 </a:solidFill>
@@ -4480,11 +5842,11 @@
                 <a:spcPct val="105000"/>
               </a:lnSpc>
               <a:spcAft>
-                <a:spcPts val="700"/>
+                <a:spcPts val="600"/>
               </a:spcAft>
             </a:pPr>
             <a:r>
-              <a:rPr sz="1250">
+              <a:rPr sz="1150">
                 <a:solidFill>
                   <a:srgbClr val="B5791A"/>
                 </a:solidFill>
@@ -4493,7 +5855,7 @@
               <a:t>■  </a:t>
             </a:r>
             <a:r>
-              <a:rPr sz="1250">
+              <a:rPr sz="1150">
                 <a:solidFill>
                   <a:srgbClr val="1A1F27"/>
                 </a:solidFill>
@@ -4609,7 +5971,7 @@
               </a:spcAft>
             </a:pPr>
             <a:r>
-              <a:rPr sz="2700" b="1">
+              <a:rPr sz="2600" b="1">
                 <a:solidFill>
                   <a:srgbClr val="1A1F27"/>
                 </a:solidFill>
@@ -4620,30 +5982,24 @@
           </a:p>
         </p:txBody>
       </p:sp>
-      <p:pic>
-        <p:nvPicPr>
-          <p:cNvPr id="4" name="Picture 3" descr="c5a.png"/>
-          <p:cNvPicPr>
-            <a:picLocks noChangeAspect="1"/>
-          </p:cNvPicPr>
+      <p:graphicFrame>
+        <p:nvGraphicFramePr>
+          <p:cNvPr id="4" name="Chart 3"/>
+          <p:cNvGraphicFramePr>
+            <a:graphicFrameLocks noGrp="1"/>
+          </p:cNvGraphicFramePr>
           <p:nvPr/>
-        </p:nvPicPr>
-        <p:blipFill>
-          <a:blip r:embed="rId2"/>
-          <a:stretch>
-            <a:fillRect/>
-          </a:stretch>
-        </p:blipFill>
-        <p:spPr>
-          <a:xfrm>
-            <a:off x="664186" y="1417320"/>
-            <a:ext cx="10833146" cy="3291840"/>
-          </a:xfrm>
-          <a:prstGeom prst="rect">
-            <a:avLst/>
-          </a:prstGeom>
-        </p:spPr>
-      </p:pic>
+        </p:nvGraphicFramePr>
+        <p:xfrm>
+          <a:off x="548640" y="1371600"/>
+          <a:ext cx="11064240" cy="3383280"/>
+        </p:xfrm>
+        <a:graphic>
+          <a:graphicData uri="http://schemas.openxmlformats.org/drawingml/2006/chart">
+            <c:chart xmlns:c="http://schemas.openxmlformats.org/drawingml/2006/chart" r:id="rId2"/>
+          </a:graphicData>
+        </a:graphic>
+      </p:graphicFrame>
       <p:sp>
         <p:nvSpPr>
           <p:cNvPr id="5" name="TextBox 4"/>
@@ -4652,8 +6008,8 @@
         </p:nvSpPr>
         <p:spPr>
           <a:xfrm>
-            <a:off x="640080" y="4937760"/>
-            <a:ext cx="10881360" cy="1645919"/>
+            <a:off x="640080" y="4892040"/>
+            <a:ext cx="10881360" cy="1783080"/>
           </a:xfrm>
           <a:prstGeom prst="rect">
             <a:avLst/>
@@ -4671,11 +6027,11 @@
                 <a:spcPct val="105000"/>
               </a:lnSpc>
               <a:spcAft>
-                <a:spcPts val="700"/>
+                <a:spcPts val="600"/>
               </a:spcAft>
             </a:pPr>
             <a:r>
-              <a:rPr sz="1300">
+              <a:rPr sz="1200">
                 <a:solidFill>
                   <a:srgbClr val="C04343"/>
                 </a:solidFill>
@@ -4684,7 +6040,7 @@
               <a:t>■  </a:t>
             </a:r>
             <a:r>
-              <a:rPr sz="1300">
+              <a:rPr sz="1200">
                 <a:solidFill>
                   <a:srgbClr val="1A1F27"/>
                 </a:solidFill>
@@ -4699,11 +6055,11 @@
                 <a:spcPct val="105000"/>
               </a:lnSpc>
               <a:spcAft>
-                <a:spcPts val="700"/>
+                <a:spcPts val="600"/>
               </a:spcAft>
             </a:pPr>
             <a:r>
-              <a:rPr sz="1300">
+              <a:rPr sz="1200">
                 <a:solidFill>
                   <a:srgbClr val="C04343"/>
                 </a:solidFill>
@@ -4712,7 +6068,7 @@
               <a:t>■  </a:t>
             </a:r>
             <a:r>
-              <a:rPr sz="1300">
+              <a:rPr sz="1200">
                 <a:solidFill>
                   <a:srgbClr val="1A1F27"/>
                 </a:solidFill>
@@ -4828,7 +6184,7 @@
               </a:spcAft>
             </a:pPr>
             <a:r>
-              <a:rPr sz="2700" b="1">
+              <a:rPr sz="2600" b="1">
                 <a:solidFill>
                   <a:srgbClr val="1A1F27"/>
                 </a:solidFill>
@@ -4839,30 +6195,24 @@
           </a:p>
         </p:txBody>
       </p:sp>
-      <p:pic>
-        <p:nvPicPr>
-          <p:cNvPr id="4" name="Picture 3" descr="c5b.png"/>
-          <p:cNvPicPr>
-            <a:picLocks noChangeAspect="1"/>
-          </p:cNvPicPr>
+      <p:graphicFrame>
+        <p:nvGraphicFramePr>
+          <p:cNvPr id="4" name="Chart 3"/>
+          <p:cNvGraphicFramePr>
+            <a:graphicFrameLocks noGrp="1"/>
+          </p:cNvGraphicFramePr>
           <p:nvPr/>
-        </p:nvPicPr>
-        <p:blipFill>
-          <a:blip r:embed="rId2"/>
-          <a:stretch>
-            <a:fillRect/>
-          </a:stretch>
-        </p:blipFill>
-        <p:spPr>
-          <a:xfrm>
-            <a:off x="664186" y="1417320"/>
-            <a:ext cx="10833146" cy="3291840"/>
-          </a:xfrm>
-          <a:prstGeom prst="rect">
-            <a:avLst/>
-          </a:prstGeom>
-        </p:spPr>
-      </p:pic>
+        </p:nvGraphicFramePr>
+        <p:xfrm>
+          <a:off x="548640" y="1371600"/>
+          <a:ext cx="11064240" cy="3383280"/>
+        </p:xfrm>
+        <a:graphic>
+          <a:graphicData uri="http://schemas.openxmlformats.org/drawingml/2006/chart">
+            <c:chart xmlns:c="http://schemas.openxmlformats.org/drawingml/2006/chart" r:id="rId2"/>
+          </a:graphicData>
+        </a:graphic>
+      </p:graphicFrame>
       <p:sp>
         <p:nvSpPr>
           <p:cNvPr id="5" name="TextBox 4"/>
@@ -4871,8 +6221,8 @@
         </p:nvSpPr>
         <p:spPr>
           <a:xfrm>
-            <a:off x="640080" y="4937760"/>
-            <a:ext cx="10881360" cy="1645919"/>
+            <a:off x="640080" y="4892040"/>
+            <a:ext cx="10881360" cy="1783080"/>
           </a:xfrm>
           <a:prstGeom prst="rect">
             <a:avLst/>
@@ -4890,11 +6240,11 @@
                 <a:spcPct val="105000"/>
               </a:lnSpc>
               <a:spcAft>
-                <a:spcPts val="700"/>
+                <a:spcPts val="600"/>
               </a:spcAft>
             </a:pPr>
             <a:r>
-              <a:rPr sz="1300">
+              <a:rPr sz="1200">
                 <a:solidFill>
                   <a:srgbClr val="B5791A"/>
                 </a:solidFill>
@@ -4903,7 +6253,7 @@
               <a:t>■  </a:t>
             </a:r>
             <a:r>
-              <a:rPr sz="1300">
+              <a:rPr sz="1200">
                 <a:solidFill>
                   <a:srgbClr val="1A1F27"/>
                 </a:solidFill>
@@ -4918,11 +6268,11 @@
                 <a:spcPct val="105000"/>
               </a:lnSpc>
               <a:spcAft>
-                <a:spcPts val="700"/>
+                <a:spcPts val="600"/>
               </a:spcAft>
             </a:pPr>
             <a:r>
-              <a:rPr sz="1300">
+              <a:rPr sz="1200">
                 <a:solidFill>
                   <a:srgbClr val="B5791A"/>
                 </a:solidFill>
@@ -4931,7 +6281,7 @@
               <a:t>■  </a:t>
             </a:r>
             <a:r>
-              <a:rPr sz="1300">
+              <a:rPr sz="1200">
                 <a:solidFill>
                   <a:srgbClr val="1A1F27"/>
                 </a:solidFill>
@@ -5091,7 +6441,7 @@
               </a:spcAft>
             </a:pPr>
             <a:r>
-              <a:rPr sz="2700" b="1">
+              <a:rPr sz="2600" b="1">
                 <a:solidFill>
                   <a:srgbClr val="1A1F27"/>
                 </a:solidFill>
@@ -5111,7 +6461,7 @@
         <p:spPr>
           <a:xfrm>
             <a:off x="548640" y="1554480"/>
-            <a:ext cx="11064240" cy="2011680"/>
+            <a:ext cx="11064240" cy="2103120"/>
           </a:xfrm>
           <a:prstGeom prst="rect">
             <a:avLst/>
@@ -5199,7 +6549,7 @@
         </p:nvSpPr>
         <p:spPr>
           <a:xfrm>
-            <a:off x="548640" y="4526280"/>
+            <a:off x="548640" y="4572000"/>
             <a:ext cx="10972800" cy="274320"/>
           </a:xfrm>
           <a:prstGeom prst="rect">
@@ -5244,8 +6594,8 @@
         </p:nvSpPr>
         <p:spPr>
           <a:xfrm>
-            <a:off x="640080" y="4892040"/>
-            <a:ext cx="10972800" cy="1691640"/>
+            <a:off x="640080" y="4937760"/>
+            <a:ext cx="10972800" cy="1737359"/>
           </a:xfrm>
           <a:prstGeom prst="rect">
             <a:avLst/>
@@ -5263,7 +6613,7 @@
                 <a:spcPct val="105000"/>
               </a:lnSpc>
               <a:spcAft>
-                <a:spcPts val="700"/>
+                <a:spcPts val="600"/>
               </a:spcAft>
             </a:pPr>
             <a:r>
@@ -5291,7 +6641,7 @@
                 <a:spcPct val="105000"/>
               </a:lnSpc>
               <a:spcAft>
-                <a:spcPts val="700"/>
+                <a:spcPts val="600"/>
               </a:spcAft>
             </a:pPr>
             <a:r>
@@ -5319,7 +6669,7 @@
                 <a:spcPct val="105000"/>
               </a:lnSpc>
               <a:spcAft>
-                <a:spcPts val="700"/>
+                <a:spcPts val="600"/>
               </a:spcAft>
             </a:pPr>
             <a:r>
@@ -5347,7 +6697,7 @@
                 <a:spcPct val="105000"/>
               </a:lnSpc>
               <a:spcAft>
-                <a:spcPts val="700"/>
+                <a:spcPts val="600"/>
               </a:spcAft>
             </a:pPr>
             <a:r>

</xml_diff>

<commit_message>
PowerPoint: vuelve a gráficos como imágenes, ahora con leyenda
Revierte a la versión con los gráficos pegados como imágenes (con las
etiquetas de datos / % por segmento) y corrige las capturas para que
incluyan la leyenda, de modo que se identifique a qué serie pertenece
cada color/valor en cada gráfico.

Co-Authored-By: Claude Opus 4.8 <noreply@anthropic.com>
Claude-Session: https://claude.ai/code/session_01VpjD3E22CD6nMXHPze7yz4
</commit_message>
<xml_diff>
--- a/Analisis_Capital_de_Trabajo_Autocity.pptx
+++ b/Analisis_Capital_de_Trabajo_Autocity.pptx
@@ -109,1374 +109,6 @@
     </a:lvl9pPr>
   </p:defaultTextStyle>
 </p:presentation>
-</file>
-
-<file path=ppt/charts/chart1.xml><?xml version="1.0" encoding="utf-8"?>
-<c:chartSpace xmlns:c="http://schemas.openxmlformats.org/drawingml/2006/chart" xmlns:a="http://schemas.openxmlformats.org/drawingml/2006/main" xmlns:r="http://schemas.openxmlformats.org/officeDocument/2006/relationships">
-  <c:date1904 val="0"/>
-  <c:chart>
-    <c:autoTitleDeleted val="1"/>
-    <c:plotArea>
-      <c:barChart>
-        <c:barDir val="col"/>
-        <c:grouping val="stacked"/>
-        <c:ser>
-          <c:idx val="0"/>
-          <c:order val="0"/>
-          <c:tx>
-            <c:strRef>
-              <c:f>Sheet1!$B$1</c:f>
-              <c:strCache>
-                <c:ptCount val="1"/>
-                <c:pt idx="0">
-                  <c:v>Rotación + trim. (sano)</c:v>
-                </c:pt>
-              </c:strCache>
-            </c:strRef>
-          </c:tx>
-          <c:spPr>
-            <a:solidFill>
-              <a:srgbClr val="3F8F6A"/>
-            </a:solidFill>
-            <a:ln>
-              <a:noFill/>
-            </a:ln>
-          </c:spPr>
-          <c:cat>
-            <c:strRef>
-              <c:f>Sheet1!$A$2:$A$12</c:f>
-              <c:strCache>
-                <c:ptCount val="11"/>
-                <c:pt idx="0">
-                  <c:v>ene '26</c:v>
-                </c:pt>
-                <c:pt idx="1">
-                  <c:v>feb '26</c:v>
-                </c:pt>
-                <c:pt idx="2">
-                  <c:v>mar '26</c:v>
-                </c:pt>
-                <c:pt idx="3">
-                  <c:v>abr '26</c:v>
-                </c:pt>
-                <c:pt idx="4">
-                  <c:v>may '26</c:v>
-                </c:pt>
-                <c:pt idx="5">
-                  <c:v>jun '26</c:v>
-                </c:pt>
-                <c:pt idx="6">
-                  <c:v>jul '26</c:v>
-                </c:pt>
-                <c:pt idx="7">
-                  <c:v>ago '26</c:v>
-                </c:pt>
-                <c:pt idx="8">
-                  <c:v>sep '26</c:v>
-                </c:pt>
-                <c:pt idx="9">
-                  <c:v>oct '26</c:v>
-                </c:pt>
-                <c:pt idx="10">
-                  <c:v>Objetivo 2027</c:v>
-                </c:pt>
-              </c:strCache>
-            </c:strRef>
-          </c:cat>
-          <c:val>
-            <c:numRef>
-              <c:f>Sheet1!$B$2:$B$12</c:f>
-              <c:numCache>
-                <c:formatCode>General</c:formatCode>
-                <c:ptCount val="11"/>
-                <c:pt idx="0">
-                  <c:v>6388</c:v>
-                </c:pt>
-                <c:pt idx="1">
-                  <c:v>6643</c:v>
-                </c:pt>
-                <c:pt idx="2">
-                  <c:v>7282</c:v>
-                </c:pt>
-                <c:pt idx="3">
-                  <c:v>7591</c:v>
-                </c:pt>
-                <c:pt idx="4">
-                  <c:v>8478</c:v>
-                </c:pt>
-                <c:pt idx="5">
-                  <c:v>8052</c:v>
-                </c:pt>
-                <c:pt idx="6">
-                  <c:v>8533</c:v>
-                </c:pt>
-                <c:pt idx="7">
-                  <c:v>8676</c:v>
-                </c:pt>
-                <c:pt idx="8">
-                  <c:v>8165</c:v>
-                </c:pt>
-                <c:pt idx="9">
-                  <c:v>8030</c:v>
-                </c:pt>
-                <c:pt idx="10">
-                  <c:v>9968</c:v>
-                </c:pt>
-              </c:numCache>
-            </c:numRef>
-          </c:val>
-        </c:ser>
-        <c:ser>
-          <c:idx val="1"/>
-          <c:order val="1"/>
-          <c:tx>
-            <c:strRef>
-              <c:f>Sheet1!$C$1</c:f>
-              <c:strCache>
-                <c:ptCount val="1"/>
-                <c:pt idx="0">
-                  <c:v>Sobrestock semestral</c:v>
-                </c:pt>
-              </c:strCache>
-            </c:strRef>
-          </c:tx>
-          <c:spPr>
-            <a:solidFill>
-              <a:srgbClr val="8A7530"/>
-            </a:solidFill>
-            <a:ln>
-              <a:noFill/>
-            </a:ln>
-          </c:spPr>
-          <c:cat>
-            <c:strRef>
-              <c:f>Sheet1!$A$2:$A$12</c:f>
-              <c:strCache>
-                <c:ptCount val="11"/>
-                <c:pt idx="0">
-                  <c:v>ene '26</c:v>
-                </c:pt>
-                <c:pt idx="1">
-                  <c:v>feb '26</c:v>
-                </c:pt>
-                <c:pt idx="2">
-                  <c:v>mar '26</c:v>
-                </c:pt>
-                <c:pt idx="3">
-                  <c:v>abr '26</c:v>
-                </c:pt>
-                <c:pt idx="4">
-                  <c:v>may '26</c:v>
-                </c:pt>
-                <c:pt idx="5">
-                  <c:v>jun '26</c:v>
-                </c:pt>
-                <c:pt idx="6">
-                  <c:v>jul '26</c:v>
-                </c:pt>
-                <c:pt idx="7">
-                  <c:v>ago '26</c:v>
-                </c:pt>
-                <c:pt idx="8">
-                  <c:v>sep '26</c:v>
-                </c:pt>
-                <c:pt idx="9">
-                  <c:v>oct '26</c:v>
-                </c:pt>
-                <c:pt idx="10">
-                  <c:v>Objetivo 2027</c:v>
-                </c:pt>
-              </c:strCache>
-            </c:strRef>
-          </c:cat>
-          <c:val>
-            <c:numRef>
-              <c:f>Sheet1!$C$2:$C$12</c:f>
-              <c:numCache>
-                <c:formatCode>General</c:formatCode>
-                <c:ptCount val="11"/>
-                <c:pt idx="0">
-                  <c:v>1987</c:v>
-                </c:pt>
-                <c:pt idx="1">
-                  <c:v>2190</c:v>
-                </c:pt>
-                <c:pt idx="2">
-                  <c:v>2204</c:v>
-                </c:pt>
-                <c:pt idx="3">
-                  <c:v>2478</c:v>
-                </c:pt>
-                <c:pt idx="4">
-                  <c:v>2009</c:v>
-                </c:pt>
-                <c:pt idx="5">
-                  <c:v>2198</c:v>
-                </c:pt>
-                <c:pt idx="6">
-                  <c:v>2047</c:v>
-                </c:pt>
-                <c:pt idx="7">
-                  <c:v>1848</c:v>
-                </c:pt>
-                <c:pt idx="8">
-                  <c:v>1978</c:v>
-                </c:pt>
-                <c:pt idx="9">
-                  <c:v>2760</c:v>
-                </c:pt>
-                <c:pt idx="10">
-                  <c:v>1216</c:v>
-                </c:pt>
-              </c:numCache>
-            </c:numRef>
-          </c:val>
-        </c:ser>
-        <c:ser>
-          <c:idx val="2"/>
-          <c:order val="2"/>
-          <c:tx>
-            <c:strRef>
-              <c:f>Sheet1!$D$1</c:f>
-              <c:strCache>
-                <c:ptCount val="1"/>
-                <c:pt idx="0">
-                  <c:v>Obsoleto (muerto + dormido)</c:v>
-                </c:pt>
-              </c:strCache>
-            </c:strRef>
-          </c:tx>
-          <c:spPr>
-            <a:solidFill>
-              <a:srgbClr val="C04343"/>
-            </a:solidFill>
-            <a:ln>
-              <a:noFill/>
-            </a:ln>
-          </c:spPr>
-          <c:cat>
-            <c:strRef>
-              <c:f>Sheet1!$A$2:$A$12</c:f>
-              <c:strCache>
-                <c:ptCount val="11"/>
-                <c:pt idx="0">
-                  <c:v>ene '26</c:v>
-                </c:pt>
-                <c:pt idx="1">
-                  <c:v>feb '26</c:v>
-                </c:pt>
-                <c:pt idx="2">
-                  <c:v>mar '26</c:v>
-                </c:pt>
-                <c:pt idx="3">
-                  <c:v>abr '26</c:v>
-                </c:pt>
-                <c:pt idx="4">
-                  <c:v>may '26</c:v>
-                </c:pt>
-                <c:pt idx="5">
-                  <c:v>jun '26</c:v>
-                </c:pt>
-                <c:pt idx="6">
-                  <c:v>jul '26</c:v>
-                </c:pt>
-                <c:pt idx="7">
-                  <c:v>ago '26</c:v>
-                </c:pt>
-                <c:pt idx="8">
-                  <c:v>sep '26</c:v>
-                </c:pt>
-                <c:pt idx="9">
-                  <c:v>oct '26</c:v>
-                </c:pt>
-                <c:pt idx="10">
-                  <c:v>Objetivo 2027</c:v>
-                </c:pt>
-              </c:strCache>
-            </c:strRef>
-          </c:cat>
-          <c:val>
-            <c:numRef>
-              <c:f>Sheet1!$D$2:$D$12</c:f>
-              <c:numCache>
-                <c:formatCode>General</c:formatCode>
-                <c:ptCount val="11"/>
-                <c:pt idx="0">
-                  <c:v>881</c:v>
-                </c:pt>
-                <c:pt idx="1">
-                  <c:v>878</c:v>
-                </c:pt>
-                <c:pt idx="2">
-                  <c:v>907</c:v>
-                </c:pt>
-                <c:pt idx="3">
-                  <c:v>953</c:v>
-                </c:pt>
-                <c:pt idx="4">
-                  <c:v>1005</c:v>
-                </c:pt>
-                <c:pt idx="5">
-                  <c:v>880</c:v>
-                </c:pt>
-                <c:pt idx="6">
-                  <c:v>921</c:v>
-                </c:pt>
-                <c:pt idx="7">
-                  <c:v>942</c:v>
-                </c:pt>
-                <c:pt idx="8">
-                  <c:v>1367</c:v>
-                </c:pt>
-                <c:pt idx="9">
-                  <c:v>1354</c:v>
-                </c:pt>
-                <c:pt idx="10">
-                  <c:v>972</c:v>
-                </c:pt>
-              </c:numCache>
-            </c:numRef>
-          </c:val>
-        </c:ser>
-        <c:overlap val="100"/>
-        <c:axId val="-2068027336"/>
-        <c:axId val="-2113994440"/>
-      </c:barChart>
-      <c:catAx>
-        <c:axId val="-2068027336"/>
-        <c:scaling>
-          <c:orientation val="minMax"/>
-        </c:scaling>
-        <c:delete val="0"/>
-        <c:axPos val="b"/>
-        <c:majorTickMark val="out"/>
-        <c:minorTickMark val="none"/>
-        <c:tickLblPos val="nextTo"/>
-        <c:txPr>
-          <a:bodyPr/>
-          <a:lstStyle/>
-          <a:p>
-            <a:pPr>
-              <a:defRPr sz="900">
-                <a:latin typeface="Calibri"/>
-              </a:defRPr>
-            </a:pPr>
-          </a:p>
-        </c:txPr>
-        <c:crossAx val="-2113994440"/>
-        <c:crosses val="autoZero"/>
-        <c:auto val="1"/>
-        <c:lblAlgn val="ctr"/>
-        <c:lblOffset val="100"/>
-        <c:noMultiLvlLbl val="0"/>
-      </c:catAx>
-      <c:valAx>
-        <c:axId val="-2113994440"/>
-        <c:scaling/>
-        <c:delete val="0"/>
-        <c:axPos val="l"/>
-        <c:majorGridlines/>
-        <c:majorTickMark val="out"/>
-        <c:minorTickMark val="none"/>
-        <c:tickLblPos val="nextTo"/>
-        <c:txPr>
-          <a:bodyPr/>
-          <a:lstStyle/>
-          <a:p>
-            <a:pPr>
-              <a:defRPr sz="900">
-                <a:latin typeface="Calibri"/>
-              </a:defRPr>
-            </a:pPr>
-          </a:p>
-        </c:txPr>
-        <c:crossAx val="-2068027336"/>
-        <c:crosses val="autoZero"/>
-      </c:valAx>
-    </c:plotArea>
-    <c:legend>
-      <c:legendPos val="t"/>
-      <c:overlay val="0"/>
-      <c:txPr>
-        <a:bodyPr/>
-        <a:lstStyle/>
-        <a:p>
-          <a:pPr>
-            <a:defRPr sz="1000">
-              <a:latin typeface="Calibri"/>
-            </a:defRPr>
-          </a:pPr>
-        </a:p>
-      </c:txPr>
-    </c:legend>
-    <c:dispBlanksAs val="gap"/>
-  </c:chart>
-  <c:txPr>
-    <a:bodyPr/>
-    <a:lstStyle/>
-    <a:p>
-      <a:pPr>
-        <a:defRPr sz="1800"/>
-      </a:pPr>
-      <a:endParaRPr lang="en-US"/>
-    </a:p>
-  </c:txPr>
-  <c:externalData r:id="rId1">
-    <c:autoUpdate val="0"/>
-  </c:externalData>
-</c:chartSpace>
-</file>
-
-<file path=ppt/charts/chart2.xml><?xml version="1.0" encoding="utf-8"?>
-<c:chartSpace xmlns:c="http://schemas.openxmlformats.org/drawingml/2006/chart" xmlns:a="http://schemas.openxmlformats.org/drawingml/2006/main" xmlns:r="http://schemas.openxmlformats.org/officeDocument/2006/relationships">
-  <c:date1904 val="0"/>
-  <c:chart>
-    <c:autoTitleDeleted val="1"/>
-    <c:plotArea>
-      <c:barChart>
-        <c:barDir val="col"/>
-        <c:grouping val="stacked"/>
-        <c:ser>
-          <c:idx val="0"/>
-          <c:order val="0"/>
-          <c:tx>
-            <c:strRef>
-              <c:f>Sheet1!$B$1</c:f>
-              <c:strCache>
-                <c:ptCount val="1"/>
-                <c:pt idx="0">
-                  <c:v>Bienes (rep + accesorios)</c:v>
-                </c:pt>
-              </c:strCache>
-            </c:strRef>
-          </c:tx>
-          <c:spPr>
-            <a:solidFill>
-              <a:srgbClr val="2F6690"/>
-            </a:solidFill>
-            <a:ln>
-              <a:noFill/>
-            </a:ln>
-          </c:spPr>
-          <c:cat>
-            <c:strRef>
-              <c:f>Sheet1!$A$2:$A$9</c:f>
-              <c:strCache>
-                <c:ptCount val="8"/>
-                <c:pt idx="0">
-                  <c:v>ene '26</c:v>
-                </c:pt>
-                <c:pt idx="1">
-                  <c:v>feb '26</c:v>
-                </c:pt>
-                <c:pt idx="2">
-                  <c:v>mar '26</c:v>
-                </c:pt>
-                <c:pt idx="3">
-                  <c:v>abr '26</c:v>
-                </c:pt>
-                <c:pt idx="4">
-                  <c:v>may '26</c:v>
-                </c:pt>
-                <c:pt idx="5">
-                  <c:v>jun '26</c:v>
-                </c:pt>
-                <c:pt idx="6">
-                  <c:v>jul '26</c:v>
-                </c:pt>
-                <c:pt idx="7">
-                  <c:v>ago '26</c:v>
-                </c:pt>
-              </c:strCache>
-            </c:strRef>
-          </c:cat>
-          <c:val>
-            <c:numRef>
-              <c:f>Sheet1!$B$2:$B$9</c:f>
-              <c:numCache>
-                <c:formatCode>General</c:formatCode>
-                <c:ptCount val="8"/>
-                <c:pt idx="0">
-                  <c:v>242</c:v>
-                </c:pt>
-                <c:pt idx="1">
-                  <c:v>79</c:v>
-                </c:pt>
-                <c:pt idx="2">
-                  <c:v>334</c:v>
-                </c:pt>
-                <c:pt idx="3">
-                  <c:v>306</c:v>
-                </c:pt>
-                <c:pt idx="4">
-                  <c:v>123</c:v>
-                </c:pt>
-                <c:pt idx="5">
-                  <c:v>287</c:v>
-                </c:pt>
-                <c:pt idx="6">
-                  <c:v>308</c:v>
-                </c:pt>
-                <c:pt idx="7">
-                  <c:v>296</c:v>
-                </c:pt>
-              </c:numCache>
-            </c:numRef>
-          </c:val>
-        </c:ser>
-        <c:ser>
-          <c:idx val="1"/>
-          <c:order val="1"/>
-          <c:tx>
-            <c:strRef>
-              <c:f>Sheet1!$C$1</c:f>
-              <c:strCache>
-                <c:ptCount val="1"/>
-                <c:pt idx="0">
-                  <c:v>Servicios (taller + siniestros)</c:v>
-                </c:pt>
-              </c:strCache>
-            </c:strRef>
-          </c:tx>
-          <c:spPr>
-            <a:solidFill>
-              <a:srgbClr val="3F8F6A"/>
-            </a:solidFill>
-            <a:ln>
-              <a:noFill/>
-            </a:ln>
-          </c:spPr>
-          <c:cat>
-            <c:strRef>
-              <c:f>Sheet1!$A$2:$A$9</c:f>
-              <c:strCache>
-                <c:ptCount val="8"/>
-                <c:pt idx="0">
-                  <c:v>ene '26</c:v>
-                </c:pt>
-                <c:pt idx="1">
-                  <c:v>feb '26</c:v>
-                </c:pt>
-                <c:pt idx="2">
-                  <c:v>mar '26</c:v>
-                </c:pt>
-                <c:pt idx="3">
-                  <c:v>abr '26</c:v>
-                </c:pt>
-                <c:pt idx="4">
-                  <c:v>may '26</c:v>
-                </c:pt>
-                <c:pt idx="5">
-                  <c:v>jun '26</c:v>
-                </c:pt>
-                <c:pt idx="6">
-                  <c:v>jul '26</c:v>
-                </c:pt>
-                <c:pt idx="7">
-                  <c:v>ago '26</c:v>
-                </c:pt>
-              </c:strCache>
-            </c:strRef>
-          </c:cat>
-          <c:val>
-            <c:numRef>
-              <c:f>Sheet1!$C$2:$C$9</c:f>
-              <c:numCache>
-                <c:formatCode>General</c:formatCode>
-                <c:ptCount val="8"/>
-                <c:pt idx="0">
-                  <c:v>175</c:v>
-                </c:pt>
-                <c:pt idx="1">
-                  <c:v>32</c:v>
-                </c:pt>
-                <c:pt idx="2">
-                  <c:v>323</c:v>
-                </c:pt>
-                <c:pt idx="3">
-                  <c:v>319</c:v>
-                </c:pt>
-                <c:pt idx="4">
-                  <c:v>203</c:v>
-                </c:pt>
-                <c:pt idx="5">
-                  <c:v>263</c:v>
-                </c:pt>
-                <c:pt idx="6">
-                  <c:v>359</c:v>
-                </c:pt>
-                <c:pt idx="7">
-                  <c:v>408</c:v>
-                </c:pt>
-              </c:numCache>
-            </c:numRef>
-          </c:val>
-        </c:ser>
-        <c:ser>
-          <c:idx val="2"/>
-          <c:order val="2"/>
-          <c:tx>
-            <c:strRef>
-              <c:f>Sheet1!$D$1</c:f>
-              <c:strCache>
-                <c:ptCount val="1"/>
-                <c:pt idx="0">
-                  <c:v>Resultados de stock</c:v>
-                </c:pt>
-              </c:strCache>
-            </c:strRef>
-          </c:tx>
-          <c:spPr>
-            <a:solidFill>
-              <a:srgbClr val="8A7530"/>
-            </a:solidFill>
-            <a:ln>
-              <a:noFill/>
-            </a:ln>
-          </c:spPr>
-          <c:cat>
-            <c:strRef>
-              <c:f>Sheet1!$A$2:$A$9</c:f>
-              <c:strCache>
-                <c:ptCount val="8"/>
-                <c:pt idx="0">
-                  <c:v>ene '26</c:v>
-                </c:pt>
-                <c:pt idx="1">
-                  <c:v>feb '26</c:v>
-                </c:pt>
-                <c:pt idx="2">
-                  <c:v>mar '26</c:v>
-                </c:pt>
-                <c:pt idx="3">
-                  <c:v>abr '26</c:v>
-                </c:pt>
-                <c:pt idx="4">
-                  <c:v>may '26</c:v>
-                </c:pt>
-                <c:pt idx="5">
-                  <c:v>jun '26</c:v>
-                </c:pt>
-                <c:pt idx="6">
-                  <c:v>jul '26</c:v>
-                </c:pt>
-                <c:pt idx="7">
-                  <c:v>ago '26</c:v>
-                </c:pt>
-              </c:strCache>
-            </c:strRef>
-          </c:cat>
-          <c:val>
-            <c:numRef>
-              <c:f>Sheet1!$D$2:$D$9</c:f>
-              <c:numCache>
-                <c:formatCode>General</c:formatCode>
-                <c:ptCount val="8"/>
-                <c:pt idx="0">
-                  <c:v>176</c:v>
-                </c:pt>
-                <c:pt idx="1">
-                  <c:v>228</c:v>
-                </c:pt>
-                <c:pt idx="2">
-                  <c:v>317</c:v>
-                </c:pt>
-                <c:pt idx="3">
-                  <c:v>131</c:v>
-                </c:pt>
-                <c:pt idx="4">
-                  <c:v>260</c:v>
-                </c:pt>
-                <c:pt idx="5">
-                  <c:v>36</c:v>
-                </c:pt>
-                <c:pt idx="6">
-                  <c:v>267</c:v>
-                </c:pt>
-                <c:pt idx="7">
-                  <c:v>-218</c:v>
-                </c:pt>
-              </c:numCache>
-            </c:numRef>
-          </c:val>
-        </c:ser>
-        <c:overlap val="100"/>
-        <c:axId val="-2068027336"/>
-        <c:axId val="-2113994440"/>
-      </c:barChart>
-      <c:lineChart>
-        <c:grouping val="standard"/>
-        <c:varyColors val="0"/>
-        <c:ser>
-          <c:idx val="9"/>
-          <c:order val="9"/>
-          <c:tx>
-            <c:strRef>
-              <c:f>Sheet1!$Z$1</c:f>
-              <c:strCache>
-                <c:ptCount val="1"/>
-                <c:pt idx="0">
-                  <c:v>Capital de trabajo (total)</c:v>
-                </c:pt>
-              </c:strCache>
-            </c:strRef>
-          </c:tx>
-          <c:spPr>
-            <a:ln w="31750">
-              <a:solidFill>
-                <a:srgbClr val="1a1f27"/>
-              </a:solidFill>
-            </a:ln>
-          </c:spPr>
-          <c:marker>
-            <c:symbol val="circle"/>
-            <c:size val="5"/>
-            <c:spPr>
-              <a:solidFill>
-                <a:srgbClr val="1a1f27"/>
-              </a:solidFill>
-              <a:ln>
-                <a:solidFill>
-                  <a:srgbClr val="1a1f27"/>
-                </a:solidFill>
-              </a:ln>
-            </c:spPr>
-          </c:marker>
-          <c:cat>
-            <c:strRef>
-              <c:f>Sheet1!$A$2:$A$9</c:f>
-              <c:strCache>
-                <c:ptCount val="8"/>
-                <c:pt idx="0">
-                  <c:v>ene '26</c:v>
-                </c:pt>
-                <c:pt idx="1">
-                  <c:v>feb '26</c:v>
-                </c:pt>
-                <c:pt idx="2">
-                  <c:v>mar '26</c:v>
-                </c:pt>
-                <c:pt idx="3">
-                  <c:v>abr '26</c:v>
-                </c:pt>
-                <c:pt idx="4">
-                  <c:v>may '26</c:v>
-                </c:pt>
-                <c:pt idx="5">
-                  <c:v>jun '26</c:v>
-                </c:pt>
-                <c:pt idx="6">
-                  <c:v>jul '26</c:v>
-                </c:pt>
-                <c:pt idx="7">
-                  <c:v>ago '26</c:v>
-                </c:pt>
-              </c:strCache>
-            </c:strRef>
-          </c:cat>
-          <c:val>
-            <c:numRef>
-              <c:f>Sheet1!$Z$2:$Z$9</c:f>
-              <c:numCache>
-                <c:formatCode>General</c:formatCode>
-                <c:ptCount val="8"/>
-                <c:pt idx="0">
-                  <c:v>9769</c:v>
-                </c:pt>
-                <c:pt idx="1">
-                  <c:v>10124</c:v>
-                </c:pt>
-                <c:pt idx="2">
-                  <c:v>10479</c:v>
-                </c:pt>
-                <c:pt idx="3">
-                  <c:v>11189</c:v>
-                </c:pt>
-                <c:pt idx="4">
-                  <c:v>11995</c:v>
-                </c:pt>
-                <c:pt idx="5">
-                  <c:v>12687</c:v>
-                </c:pt>
-                <c:pt idx="6">
-                  <c:v>12367</c:v>
-                </c:pt>
-                <c:pt idx="7">
-                  <c:v>13962</c:v>
-                </c:pt>
-              </c:numCache>
-            </c:numRef>
-          </c:val>
-          <c:smooth val="0"/>
-        </c:ser>
-        <c:marker val="1"/>
-        <c:axId val="800"/>
-        <c:axId val="900"/>
-      </c:lineChart>
-      <c:catAx>
-        <c:axId val="-2068027336"/>
-        <c:scaling>
-          <c:orientation val="minMax"/>
-        </c:scaling>
-        <c:delete val="0"/>
-        <c:axPos val="b"/>
-        <c:majorTickMark val="out"/>
-        <c:minorTickMark val="none"/>
-        <c:tickLblPos val="nextTo"/>
-        <c:txPr>
-          <a:bodyPr/>
-          <a:lstStyle/>
-          <a:p>
-            <a:pPr>
-              <a:defRPr sz="900">
-                <a:latin typeface="Calibri"/>
-              </a:defRPr>
-            </a:pPr>
-          </a:p>
-        </c:txPr>
-        <c:crossAx val="-2113994440"/>
-        <c:crosses val="autoZero"/>
-        <c:auto val="1"/>
-        <c:lblAlgn val="ctr"/>
-        <c:lblOffset val="100"/>
-        <c:noMultiLvlLbl val="0"/>
-      </c:catAx>
-      <c:valAx>
-        <c:axId val="-2113994440"/>
-        <c:scaling/>
-        <c:delete val="0"/>
-        <c:axPos val="l"/>
-        <c:majorGridlines/>
-        <c:majorTickMark val="out"/>
-        <c:minorTickMark val="none"/>
-        <c:tickLblPos val="nextTo"/>
-        <c:txPr>
-          <a:bodyPr/>
-          <a:lstStyle/>
-          <a:p>
-            <a:pPr>
-              <a:defRPr sz="900">
-                <a:latin typeface="Calibri"/>
-              </a:defRPr>
-            </a:pPr>
-          </a:p>
-        </c:txPr>
-        <c:crossAx val="-2068027336"/>
-        <c:crosses val="autoZero"/>
-      </c:valAx>
-      <c:catAx>
-        <c:axId val="800"/>
-        <c:scaling>
-          <c:orientation val="minMax"/>
-        </c:scaling>
-        <c:delete val="1"/>
-        <c:axPos val="b"/>
-        <c:majorTickMark val="none"/>
-        <c:minorTickMark val="none"/>
-        <c:tickLblPos val="none"/>
-        <c:crossAx val="900"/>
-      </c:catAx>
-      <c:valAx>
-        <c:axId val="900"/>
-        <c:scaling>
-          <c:orientation val="minMax"/>
-        </c:scaling>
-        <c:delete val="0"/>
-        <c:axPos val="r"/>
-        <c:numFmt formatCode="&quot;$&quot;#,##0" sourceLinked="0"/>
-        <c:majorTickMark val="out"/>
-        <c:minorTickMark val="none"/>
-        <c:tickLblPos val="nextTo"/>
-        <c:crossAx val="800"/>
-        <c:crosses val="max"/>
-      </c:valAx>
-    </c:plotArea>
-    <c:legend>
-      <c:legendPos val="t"/>
-      <c:overlay val="0"/>
-      <c:txPr>
-        <a:bodyPr/>
-        <a:lstStyle/>
-        <a:p>
-          <a:pPr>
-            <a:defRPr sz="1000">
-              <a:latin typeface="Calibri"/>
-            </a:defRPr>
-          </a:pPr>
-        </a:p>
-      </c:txPr>
-    </c:legend>
-    <c:dispBlanksAs val="gap"/>
-  </c:chart>
-  <c:txPr>
-    <a:bodyPr/>
-    <a:lstStyle/>
-    <a:p>
-      <a:pPr>
-        <a:defRPr sz="1800"/>
-      </a:pPr>
-      <a:endParaRPr lang="en-US"/>
-    </a:p>
-  </c:txPr>
-  <c:externalData r:id="rId1">
-    <c:autoUpdate val="0"/>
-  </c:externalData>
-</c:chartSpace>
-</file>
-
-<file path=ppt/charts/chart3.xml><?xml version="1.0" encoding="utf-8"?>
-<c:chartSpace xmlns:c="http://schemas.openxmlformats.org/drawingml/2006/chart" xmlns:a="http://schemas.openxmlformats.org/drawingml/2006/main" xmlns:r="http://schemas.openxmlformats.org/officeDocument/2006/relationships">
-  <c:date1904 val="0"/>
-  <c:chart>
-    <c:autoTitleDeleted val="1"/>
-    <c:plotArea>
-      <c:lineChart>
-        <c:grouping val="standard"/>
-        <c:varyColors val="0"/>
-        <c:ser>
-          <c:idx val="0"/>
-          <c:order val="0"/>
-          <c:tx>
-            <c:strRef>
-              <c:f>Sheet1!$B$1</c:f>
-              <c:strCache>
-                <c:ptCount val="1"/>
-                <c:pt idx="0">
-                  <c:v>Bienes</c:v>
-                </c:pt>
-              </c:strCache>
-            </c:strRef>
-          </c:tx>
-          <c:spPr>
-            <a:ln w="25400">
-              <a:solidFill>
-                <a:srgbClr val="2F6690"/>
-              </a:solidFill>
-            </a:ln>
-          </c:spPr>
-          <c:cat>
-            <c:strRef>
-              <c:f>Sheet1!$A$2:$A$9</c:f>
-              <c:strCache>
-                <c:ptCount val="8"/>
-                <c:pt idx="0">
-                  <c:v>ene '26</c:v>
-                </c:pt>
-                <c:pt idx="1">
-                  <c:v>feb '26</c:v>
-                </c:pt>
-                <c:pt idx="2">
-                  <c:v>mar '26</c:v>
-                </c:pt>
-                <c:pt idx="3">
-                  <c:v>abr '26</c:v>
-                </c:pt>
-                <c:pt idx="4">
-                  <c:v>may '26</c:v>
-                </c:pt>
-                <c:pt idx="5">
-                  <c:v>jun '26</c:v>
-                </c:pt>
-                <c:pt idx="6">
-                  <c:v>jul '26</c:v>
-                </c:pt>
-                <c:pt idx="7">
-                  <c:v>ago '26</c:v>
-                </c:pt>
-              </c:strCache>
-            </c:strRef>
-          </c:cat>
-          <c:val>
-            <c:numRef>
-              <c:f>Sheet1!$B$2:$B$9</c:f>
-              <c:numCache>
-                <c:formatCode>General</c:formatCode>
-                <c:ptCount val="8"/>
-                <c:pt idx="0">
-                  <c:v>2.48</c:v>
-                </c:pt>
-                <c:pt idx="1">
-                  <c:v>0.78</c:v>
-                </c:pt>
-                <c:pt idx="2">
-                  <c:v>3.19</c:v>
-                </c:pt>
-                <c:pt idx="3">
-                  <c:v>2.73</c:v>
-                </c:pt>
-                <c:pt idx="4">
-                  <c:v>1.03</c:v>
-                </c:pt>
-                <c:pt idx="5">
-                  <c:v>2.26</c:v>
-                </c:pt>
-                <c:pt idx="6">
-                  <c:v>2.49</c:v>
-                </c:pt>
-                <c:pt idx="7">
-                  <c:v>2.12</c:v>
-                </c:pt>
-              </c:numCache>
-            </c:numRef>
-          </c:val>
-          <c:smooth val="0"/>
-        </c:ser>
-        <c:ser>
-          <c:idx val="1"/>
-          <c:order val="1"/>
-          <c:tx>
-            <c:strRef>
-              <c:f>Sheet1!$C$1</c:f>
-              <c:strCache>
-                <c:ptCount val="1"/>
-                <c:pt idx="0">
-                  <c:v>Servicios</c:v>
-                </c:pt>
-              </c:strCache>
-            </c:strRef>
-          </c:tx>
-          <c:spPr>
-            <a:ln w="25400">
-              <a:solidFill>
-                <a:srgbClr val="3F8F6A"/>
-              </a:solidFill>
-            </a:ln>
-          </c:spPr>
-          <c:cat>
-            <c:strRef>
-              <c:f>Sheet1!$A$2:$A$9</c:f>
-              <c:strCache>
-                <c:ptCount val="8"/>
-                <c:pt idx="0">
-                  <c:v>ene '26</c:v>
-                </c:pt>
-                <c:pt idx="1">
-                  <c:v>feb '26</c:v>
-                </c:pt>
-                <c:pt idx="2">
-                  <c:v>mar '26</c:v>
-                </c:pt>
-                <c:pt idx="3">
-                  <c:v>abr '26</c:v>
-                </c:pt>
-                <c:pt idx="4">
-                  <c:v>may '26</c:v>
-                </c:pt>
-                <c:pt idx="5">
-                  <c:v>jun '26</c:v>
-                </c:pt>
-                <c:pt idx="6">
-                  <c:v>jul '26</c:v>
-                </c:pt>
-                <c:pt idx="7">
-                  <c:v>ago '26</c:v>
-                </c:pt>
-              </c:strCache>
-            </c:strRef>
-          </c:cat>
-          <c:val>
-            <c:numRef>
-              <c:f>Sheet1!$C$2:$C$9</c:f>
-              <c:numCache>
-                <c:formatCode>General</c:formatCode>
-                <c:ptCount val="8"/>
-                <c:pt idx="0">
-                  <c:v>1.79</c:v>
-                </c:pt>
-                <c:pt idx="1">
-                  <c:v>0.32</c:v>
-                </c:pt>
-                <c:pt idx="2">
-                  <c:v>3.08</c:v>
-                </c:pt>
-                <c:pt idx="3">
-                  <c:v>2.85</c:v>
-                </c:pt>
-                <c:pt idx="4">
-                  <c:v>1.69</c:v>
-                </c:pt>
-                <c:pt idx="5">
-                  <c:v>2.07</c:v>
-                </c:pt>
-                <c:pt idx="6">
-                  <c:v>2.9</c:v>
-                </c:pt>
-                <c:pt idx="7">
-                  <c:v>2.92</c:v>
-                </c:pt>
-              </c:numCache>
-            </c:numRef>
-          </c:val>
-          <c:smooth val="0"/>
-        </c:ser>
-        <c:ser>
-          <c:idx val="2"/>
-          <c:order val="2"/>
-          <c:tx>
-            <c:strRef>
-              <c:f>Sheet1!$D$1</c:f>
-              <c:strCache>
-                <c:ptCount val="1"/>
-                <c:pt idx="0">
-                  <c:v>Resultados de stock</c:v>
-                </c:pt>
-              </c:strCache>
-            </c:strRef>
-          </c:tx>
-          <c:spPr>
-            <a:ln w="25400">
-              <a:solidFill>
-                <a:srgbClr val="8A7530"/>
-              </a:solidFill>
-            </a:ln>
-          </c:spPr>
-          <c:cat>
-            <c:strRef>
-              <c:f>Sheet1!$A$2:$A$9</c:f>
-              <c:strCache>
-                <c:ptCount val="8"/>
-                <c:pt idx="0">
-                  <c:v>ene '26</c:v>
-                </c:pt>
-                <c:pt idx="1">
-                  <c:v>feb '26</c:v>
-                </c:pt>
-                <c:pt idx="2">
-                  <c:v>mar '26</c:v>
-                </c:pt>
-                <c:pt idx="3">
-                  <c:v>abr '26</c:v>
-                </c:pt>
-                <c:pt idx="4">
-                  <c:v>may '26</c:v>
-                </c:pt>
-                <c:pt idx="5">
-                  <c:v>jun '26</c:v>
-                </c:pt>
-                <c:pt idx="6">
-                  <c:v>jul '26</c:v>
-                </c:pt>
-                <c:pt idx="7">
-                  <c:v>ago '26</c:v>
-                </c:pt>
-              </c:strCache>
-            </c:strRef>
-          </c:cat>
-          <c:val>
-            <c:numRef>
-              <c:f>Sheet1!$D$2:$D$9</c:f>
-              <c:numCache>
-                <c:formatCode>General</c:formatCode>
-                <c:ptCount val="8"/>
-                <c:pt idx="0">
-                  <c:v>1.8</c:v>
-                </c:pt>
-                <c:pt idx="1">
-                  <c:v>2.25</c:v>
-                </c:pt>
-                <c:pt idx="2">
-                  <c:v>3.03</c:v>
-                </c:pt>
-                <c:pt idx="3">
-                  <c:v>1.17</c:v>
-                </c:pt>
-                <c:pt idx="4">
-                  <c:v>2.17</c:v>
-                </c:pt>
-                <c:pt idx="5">
-                  <c:v>0.28</c:v>
-                </c:pt>
-                <c:pt idx="6">
-                  <c:v>2.16</c:v>
-                </c:pt>
-                <c:pt idx="7">
-                  <c:v>-1.56</c:v>
-                </c:pt>
-              </c:numCache>
-            </c:numRef>
-          </c:val>
-          <c:smooth val="0"/>
-        </c:ser>
-        <c:ser>
-          <c:idx val="3"/>
-          <c:order val="3"/>
-          <c:tx>
-            <c:strRef>
-              <c:f>Sheet1!$E$1</c:f>
-              <c:strCache>
-                <c:ptCount val="1"/>
-                <c:pt idx="0">
-                  <c:v>Total</c:v>
-                </c:pt>
-              </c:strCache>
-            </c:strRef>
-          </c:tx>
-          <c:spPr>
-            <a:ln w="38100">
-              <a:solidFill>
-                <a:srgbClr val="1A1F27"/>
-              </a:solidFill>
-            </a:ln>
-          </c:spPr>
-          <c:cat>
-            <c:strRef>
-              <c:f>Sheet1!$A$2:$A$9</c:f>
-              <c:strCache>
-                <c:ptCount val="8"/>
-                <c:pt idx="0">
-                  <c:v>ene '26</c:v>
-                </c:pt>
-                <c:pt idx="1">
-                  <c:v>feb '26</c:v>
-                </c:pt>
-                <c:pt idx="2">
-                  <c:v>mar '26</c:v>
-                </c:pt>
-                <c:pt idx="3">
-                  <c:v>abr '26</c:v>
-                </c:pt>
-                <c:pt idx="4">
-                  <c:v>may '26</c:v>
-                </c:pt>
-                <c:pt idx="5">
-                  <c:v>jun '26</c:v>
-                </c:pt>
-                <c:pt idx="6">
-                  <c:v>jul '26</c:v>
-                </c:pt>
-                <c:pt idx="7">
-                  <c:v>ago '26</c:v>
-                </c:pt>
-              </c:strCache>
-            </c:strRef>
-          </c:cat>
-          <c:val>
-            <c:numRef>
-              <c:f>Sheet1!$E$2:$E$9</c:f>
-              <c:numCache>
-                <c:formatCode>General</c:formatCode>
-                <c:ptCount val="8"/>
-                <c:pt idx="0">
-                  <c:v>6.07</c:v>
-                </c:pt>
-                <c:pt idx="1">
-                  <c:v>3.35</c:v>
-                </c:pt>
-                <c:pt idx="2">
-                  <c:v>9.29</c:v>
-                </c:pt>
-                <c:pt idx="3">
-                  <c:v>6.76</c:v>
-                </c:pt>
-                <c:pt idx="4">
-                  <c:v>4.89</c:v>
-                </c:pt>
-                <c:pt idx="5">
-                  <c:v>4.62</c:v>
-                </c:pt>
-                <c:pt idx="6">
-                  <c:v>7.55</c:v>
-                </c:pt>
-                <c:pt idx="7">
-                  <c:v>3.48</c:v>
-                </c:pt>
-              </c:numCache>
-            </c:numRef>
-          </c:val>
-          <c:smooth val="0"/>
-        </c:ser>
-        <c:marker val="1"/>
-        <c:smooth val="0"/>
-        <c:axId val="2118791784"/>
-        <c:axId val="2140495176"/>
-      </c:lineChart>
-      <c:catAx>
-        <c:axId val="2118791784"/>
-        <c:scaling>
-          <c:orientation val="minMax"/>
-        </c:scaling>
-        <c:delete val="0"/>
-        <c:axPos val="b"/>
-        <c:majorTickMark val="out"/>
-        <c:minorTickMark val="none"/>
-        <c:tickLblPos val="nextTo"/>
-        <c:txPr>
-          <a:bodyPr/>
-          <a:lstStyle/>
-          <a:p>
-            <a:pPr>
-              <a:defRPr sz="900">
-                <a:latin typeface="Calibri"/>
-              </a:defRPr>
-            </a:pPr>
-          </a:p>
-        </c:txPr>
-        <c:crossAx val="2140495176"/>
-        <c:crosses val="autoZero"/>
-        <c:auto val="1"/>
-        <c:lblAlgn val="ctr"/>
-        <c:lblOffset val="100"/>
-        <c:noMultiLvlLbl val="0"/>
-      </c:catAx>
-      <c:valAx>
-        <c:axId val="2140495176"/>
-        <c:scaling/>
-        <c:delete val="0"/>
-        <c:axPos val="l"/>
-        <c:majorGridlines/>
-        <c:numFmt formatCode="0&quot;%&quot;" sourceLinked="0"/>
-        <c:majorTickMark val="out"/>
-        <c:minorTickMark val="none"/>
-        <c:tickLblPos val="nextTo"/>
-        <c:txPr>
-          <a:bodyPr/>
-          <a:lstStyle/>
-          <a:p>
-            <a:pPr>
-              <a:defRPr sz="900">
-                <a:latin typeface="Calibri"/>
-              </a:defRPr>
-            </a:pPr>
-          </a:p>
-        </c:txPr>
-        <c:crossAx val="2118791784"/>
-        <c:crosses val="autoZero"/>
-      </c:valAx>
-    </c:plotArea>
-    <c:legend>
-      <c:legendPos val="t"/>
-      <c:layout/>
-      <c:overlay val="0"/>
-      <c:txPr>
-        <a:bodyPr/>
-        <a:lstStyle/>
-        <a:p>
-          <a:pPr>
-            <a:defRPr sz="1000">
-              <a:latin typeface="Calibri"/>
-            </a:defRPr>
-          </a:pPr>
-        </a:p>
-      </c:txPr>
-    </c:legend>
-    <c:plotVisOnly val="1"/>
-    <c:dispBlanksAs val="gap"/>
-    <c:showDLblsOverMax val="0"/>
-  </c:chart>
-  <c:txPr>
-    <a:bodyPr/>
-    <a:lstStyle/>
-    <a:p>
-      <a:pPr>
-        <a:defRPr sz="1800"/>
-      </a:pPr>
-      <a:endParaRPr lang="en-US"/>
-    </a:p>
-  </c:txPr>
-  <c:externalData r:id="rId1">
-    <c:autoUpdate val="0"/>
-  </c:externalData>
-</c:chartSpace>
 </file>
 
 <file path=ppt/slideLayouts/slideLayout1.xml><?xml version="1.0" encoding="utf-8"?>
@@ -5592,7 +4224,7 @@
                 </a:solidFill>
                 <a:latin typeface="Calibri"/>
               </a:rPr>
-              <a:t>Autocity · Posventa (repuestos, taller, siniestros, accesorios) · $ millones</a:t>
+              <a:t>Autocity · Posventa (repuestos, taller, siniestros, accesorios) · $ millones · fuente: cuadros de resultados y planilla de capital de trabajo</a:t>
             </a:r>
           </a:p>
         </p:txBody>
@@ -5702,7 +4334,7 @@
               </a:spcAft>
             </a:pPr>
             <a:r>
-              <a:rPr sz="2600" b="1">
+              <a:rPr sz="2700" b="1">
                 <a:solidFill>
                   <a:srgbClr val="1A1F27"/>
                 </a:solidFill>
@@ -5713,24 +4345,30 @@
           </a:p>
         </p:txBody>
       </p:sp>
-      <p:graphicFrame>
-        <p:nvGraphicFramePr>
-          <p:cNvPr id="4" name="Chart 3"/>
-          <p:cNvGraphicFramePr>
-            <a:graphicFrameLocks noGrp="1"/>
-          </p:cNvGraphicFramePr>
+      <p:pic>
+        <p:nvPicPr>
+          <p:cNvPr id="4" name="Picture 3" descr="c1.png"/>
+          <p:cNvPicPr>
+            <a:picLocks noChangeAspect="1"/>
+          </p:cNvPicPr>
           <p:nvPr/>
-        </p:nvGraphicFramePr>
-        <p:xfrm>
-          <a:off x="548640" y="1371600"/>
-          <a:ext cx="11064240" cy="3520440"/>
-        </p:xfrm>
-        <a:graphic>
-          <a:graphicData uri="http://schemas.openxmlformats.org/drawingml/2006/chart">
-            <c:chart xmlns:c="http://schemas.openxmlformats.org/drawingml/2006/chart" r:id="rId2"/>
-          </a:graphicData>
-        </a:graphic>
-      </p:graphicFrame>
+        </p:nvPicPr>
+        <p:blipFill>
+          <a:blip r:embed="rId2"/>
+          <a:stretch>
+            <a:fillRect/>
+          </a:stretch>
+        </p:blipFill>
+        <p:spPr>
+          <a:xfrm>
+            <a:off x="1024327" y="1417320"/>
+            <a:ext cx="10112864" cy="3383280"/>
+          </a:xfrm>
+          <a:prstGeom prst="rect">
+            <a:avLst/>
+          </a:prstGeom>
+        </p:spPr>
+      </p:pic>
       <p:sp>
         <p:nvSpPr>
           <p:cNvPr id="5" name="TextBox 4"/>
@@ -5739,8 +4377,8 @@
         </p:nvSpPr>
         <p:spPr>
           <a:xfrm>
-            <a:off x="640080" y="5029200"/>
-            <a:ext cx="10881360" cy="1645920"/>
+            <a:off x="640080" y="4983480"/>
+            <a:ext cx="10881360" cy="1600199"/>
           </a:xfrm>
           <a:prstGeom prst="rect">
             <a:avLst/>
@@ -5758,11 +4396,11 @@
                 <a:spcPct val="105000"/>
               </a:lnSpc>
               <a:spcAft>
-                <a:spcPts val="600"/>
+                <a:spcPts val="700"/>
               </a:spcAft>
             </a:pPr>
             <a:r>
-              <a:rPr sz="1150">
+              <a:rPr sz="1250">
                 <a:solidFill>
                   <a:srgbClr val="2F9E5C"/>
                 </a:solidFill>
@@ -5771,7 +4409,7 @@
               <a:t>■  </a:t>
             </a:r>
             <a:r>
-              <a:rPr sz="1150">
+              <a:rPr sz="1250">
                 <a:solidFill>
                   <a:srgbClr val="1A1F27"/>
                 </a:solidFill>
@@ -5786,11 +4424,11 @@
                 <a:spcPct val="105000"/>
               </a:lnSpc>
               <a:spcAft>
-                <a:spcPts val="600"/>
+                <a:spcPts val="700"/>
               </a:spcAft>
             </a:pPr>
             <a:r>
-              <a:rPr sz="1150">
+              <a:rPr sz="1250">
                 <a:solidFill>
                   <a:srgbClr val="C04343"/>
                 </a:solidFill>
@@ -5799,7 +4437,7 @@
               <a:t>■  </a:t>
             </a:r>
             <a:r>
-              <a:rPr sz="1150">
+              <a:rPr sz="1250">
                 <a:solidFill>
                   <a:srgbClr val="1A1F27"/>
                 </a:solidFill>
@@ -5814,11 +4452,11 @@
                 <a:spcPct val="105000"/>
               </a:lnSpc>
               <a:spcAft>
-                <a:spcPts val="600"/>
+                <a:spcPts val="700"/>
               </a:spcAft>
             </a:pPr>
             <a:r>
-              <a:rPr sz="1150">
+              <a:rPr sz="1250">
                 <a:solidFill>
                   <a:srgbClr val="C04343"/>
                 </a:solidFill>
@@ -5827,7 +4465,7 @@
               <a:t>■  </a:t>
             </a:r>
             <a:r>
-              <a:rPr sz="1150">
+              <a:rPr sz="1250">
                 <a:solidFill>
                   <a:srgbClr val="1A1F27"/>
                 </a:solidFill>
@@ -5842,11 +4480,11 @@
                 <a:spcPct val="105000"/>
               </a:lnSpc>
               <a:spcAft>
-                <a:spcPts val="600"/>
+                <a:spcPts val="700"/>
               </a:spcAft>
             </a:pPr>
             <a:r>
-              <a:rPr sz="1150">
+              <a:rPr sz="1250">
                 <a:solidFill>
                   <a:srgbClr val="B5791A"/>
                 </a:solidFill>
@@ -5855,7 +4493,7 @@
               <a:t>■  </a:t>
             </a:r>
             <a:r>
-              <a:rPr sz="1150">
+              <a:rPr sz="1250">
                 <a:solidFill>
                   <a:srgbClr val="1A1F27"/>
                 </a:solidFill>
@@ -5971,7 +4609,7 @@
               </a:spcAft>
             </a:pPr>
             <a:r>
-              <a:rPr sz="2600" b="1">
+              <a:rPr sz="2700" b="1">
                 <a:solidFill>
                   <a:srgbClr val="1A1F27"/>
                 </a:solidFill>
@@ -5982,24 +4620,30 @@
           </a:p>
         </p:txBody>
       </p:sp>
-      <p:graphicFrame>
-        <p:nvGraphicFramePr>
-          <p:cNvPr id="4" name="Chart 3"/>
-          <p:cNvGraphicFramePr>
-            <a:graphicFrameLocks noGrp="1"/>
-          </p:cNvGraphicFramePr>
+      <p:pic>
+        <p:nvPicPr>
+          <p:cNvPr id="4" name="Picture 3" descr="c5a.png"/>
+          <p:cNvPicPr>
+            <a:picLocks noChangeAspect="1"/>
+          </p:cNvPicPr>
           <p:nvPr/>
-        </p:nvGraphicFramePr>
-        <p:xfrm>
-          <a:off x="548640" y="1371600"/>
-          <a:ext cx="11064240" cy="3383280"/>
-        </p:xfrm>
-        <a:graphic>
-          <a:graphicData uri="http://schemas.openxmlformats.org/drawingml/2006/chart">
-            <c:chart xmlns:c="http://schemas.openxmlformats.org/drawingml/2006/chart" r:id="rId2"/>
-          </a:graphicData>
-        </a:graphic>
-      </p:graphicFrame>
+        </p:nvPicPr>
+        <p:blipFill>
+          <a:blip r:embed="rId2"/>
+          <a:stretch>
+            <a:fillRect/>
+          </a:stretch>
+        </p:blipFill>
+        <p:spPr>
+          <a:xfrm>
+            <a:off x="1160988" y="1417320"/>
+            <a:ext cx="9839543" cy="3291840"/>
+          </a:xfrm>
+          <a:prstGeom prst="rect">
+            <a:avLst/>
+          </a:prstGeom>
+        </p:spPr>
+      </p:pic>
       <p:sp>
         <p:nvSpPr>
           <p:cNvPr id="5" name="TextBox 4"/>
@@ -6008,8 +4652,8 @@
         </p:nvSpPr>
         <p:spPr>
           <a:xfrm>
-            <a:off x="640080" y="4892040"/>
-            <a:ext cx="10881360" cy="1783080"/>
+            <a:off x="640080" y="4937760"/>
+            <a:ext cx="10881360" cy="1645919"/>
           </a:xfrm>
           <a:prstGeom prst="rect">
             <a:avLst/>
@@ -6027,11 +4671,11 @@
                 <a:spcPct val="105000"/>
               </a:lnSpc>
               <a:spcAft>
-                <a:spcPts val="600"/>
+                <a:spcPts val="700"/>
               </a:spcAft>
             </a:pPr>
             <a:r>
-              <a:rPr sz="1200">
+              <a:rPr sz="1300">
                 <a:solidFill>
                   <a:srgbClr val="C04343"/>
                 </a:solidFill>
@@ -6040,7 +4684,7 @@
               <a:t>■  </a:t>
             </a:r>
             <a:r>
-              <a:rPr sz="1200">
+              <a:rPr sz="1300">
                 <a:solidFill>
                   <a:srgbClr val="1A1F27"/>
                 </a:solidFill>
@@ -6055,11 +4699,11 @@
                 <a:spcPct val="105000"/>
               </a:lnSpc>
               <a:spcAft>
-                <a:spcPts val="600"/>
+                <a:spcPts val="700"/>
               </a:spcAft>
             </a:pPr>
             <a:r>
-              <a:rPr sz="1200">
+              <a:rPr sz="1300">
                 <a:solidFill>
                   <a:srgbClr val="C04343"/>
                 </a:solidFill>
@@ -6068,7 +4712,7 @@
               <a:t>■  </a:t>
             </a:r>
             <a:r>
-              <a:rPr sz="1200">
+              <a:rPr sz="1300">
                 <a:solidFill>
                   <a:srgbClr val="1A1F27"/>
                 </a:solidFill>
@@ -6184,7 +4828,7 @@
               </a:spcAft>
             </a:pPr>
             <a:r>
-              <a:rPr sz="2600" b="1">
+              <a:rPr sz="2700" b="1">
                 <a:solidFill>
                   <a:srgbClr val="1A1F27"/>
                 </a:solidFill>
@@ -6195,24 +4839,30 @@
           </a:p>
         </p:txBody>
       </p:sp>
-      <p:graphicFrame>
-        <p:nvGraphicFramePr>
-          <p:cNvPr id="4" name="Chart 3"/>
-          <p:cNvGraphicFramePr>
-            <a:graphicFrameLocks noGrp="1"/>
-          </p:cNvGraphicFramePr>
+      <p:pic>
+        <p:nvPicPr>
+          <p:cNvPr id="4" name="Picture 3" descr="c5b.png"/>
+          <p:cNvPicPr>
+            <a:picLocks noChangeAspect="1"/>
+          </p:cNvPicPr>
           <p:nvPr/>
-        </p:nvGraphicFramePr>
-        <p:xfrm>
-          <a:off x="548640" y="1371600"/>
-          <a:ext cx="11064240" cy="3383280"/>
-        </p:xfrm>
-        <a:graphic>
-          <a:graphicData uri="http://schemas.openxmlformats.org/drawingml/2006/chart">
-            <c:chart xmlns:c="http://schemas.openxmlformats.org/drawingml/2006/chart" r:id="rId2"/>
-          </a:graphicData>
-        </a:graphic>
-      </p:graphicFrame>
+        </p:nvPicPr>
+        <p:blipFill>
+          <a:blip r:embed="rId2"/>
+          <a:stretch>
+            <a:fillRect/>
+          </a:stretch>
+        </p:blipFill>
+        <p:spPr>
+          <a:xfrm>
+            <a:off x="1160988" y="1417320"/>
+            <a:ext cx="9839543" cy="3291840"/>
+          </a:xfrm>
+          <a:prstGeom prst="rect">
+            <a:avLst/>
+          </a:prstGeom>
+        </p:spPr>
+      </p:pic>
       <p:sp>
         <p:nvSpPr>
           <p:cNvPr id="5" name="TextBox 4"/>
@@ -6221,8 +4871,8 @@
         </p:nvSpPr>
         <p:spPr>
           <a:xfrm>
-            <a:off x="640080" y="4892040"/>
-            <a:ext cx="10881360" cy="1783080"/>
+            <a:off x="640080" y="4937760"/>
+            <a:ext cx="10881360" cy="1645919"/>
           </a:xfrm>
           <a:prstGeom prst="rect">
             <a:avLst/>
@@ -6240,11 +4890,11 @@
                 <a:spcPct val="105000"/>
               </a:lnSpc>
               <a:spcAft>
-                <a:spcPts val="600"/>
+                <a:spcPts val="700"/>
               </a:spcAft>
             </a:pPr>
             <a:r>
-              <a:rPr sz="1200">
+              <a:rPr sz="1300">
                 <a:solidFill>
                   <a:srgbClr val="B5791A"/>
                 </a:solidFill>
@@ -6253,7 +4903,7 @@
               <a:t>■  </a:t>
             </a:r>
             <a:r>
-              <a:rPr sz="1200">
+              <a:rPr sz="1300">
                 <a:solidFill>
                   <a:srgbClr val="1A1F27"/>
                 </a:solidFill>
@@ -6268,11 +4918,11 @@
                 <a:spcPct val="105000"/>
               </a:lnSpc>
               <a:spcAft>
-                <a:spcPts val="600"/>
+                <a:spcPts val="700"/>
               </a:spcAft>
             </a:pPr>
             <a:r>
-              <a:rPr sz="1200">
+              <a:rPr sz="1300">
                 <a:solidFill>
                   <a:srgbClr val="B5791A"/>
                 </a:solidFill>
@@ -6281,7 +4931,7 @@
               <a:t>■  </a:t>
             </a:r>
             <a:r>
-              <a:rPr sz="1200">
+              <a:rPr sz="1300">
                 <a:solidFill>
                   <a:srgbClr val="1A1F27"/>
                 </a:solidFill>
@@ -6441,7 +5091,7 @@
               </a:spcAft>
             </a:pPr>
             <a:r>
-              <a:rPr sz="2600" b="1">
+              <a:rPr sz="2700" b="1">
                 <a:solidFill>
                   <a:srgbClr val="1A1F27"/>
                 </a:solidFill>
@@ -6461,7 +5111,7 @@
         <p:spPr>
           <a:xfrm>
             <a:off x="548640" y="1554480"/>
-            <a:ext cx="11064240" cy="2103120"/>
+            <a:ext cx="11064240" cy="2011680"/>
           </a:xfrm>
           <a:prstGeom prst="rect">
             <a:avLst/>
@@ -6549,7 +5199,7 @@
         </p:nvSpPr>
         <p:spPr>
           <a:xfrm>
-            <a:off x="548640" y="4572000"/>
+            <a:off x="548640" y="4526280"/>
             <a:ext cx="10972800" cy="274320"/>
           </a:xfrm>
           <a:prstGeom prst="rect">
@@ -6594,8 +5244,8 @@
         </p:nvSpPr>
         <p:spPr>
           <a:xfrm>
-            <a:off x="640080" y="4937760"/>
-            <a:ext cx="10972800" cy="1737359"/>
+            <a:off x="640080" y="4892040"/>
+            <a:ext cx="10972800" cy="1691640"/>
           </a:xfrm>
           <a:prstGeom prst="rect">
             <a:avLst/>
@@ -6613,7 +5263,7 @@
                 <a:spcPct val="105000"/>
               </a:lnSpc>
               <a:spcAft>
-                <a:spcPts val="600"/>
+                <a:spcPts val="700"/>
               </a:spcAft>
             </a:pPr>
             <a:r>
@@ -6641,7 +5291,7 @@
                 <a:spcPct val="105000"/>
               </a:lnSpc>
               <a:spcAft>
-                <a:spcPts val="600"/>
+                <a:spcPts val="700"/>
               </a:spcAft>
             </a:pPr>
             <a:r>
@@ -6669,7 +5319,7 @@
                 <a:spcPct val="105000"/>
               </a:lnSpc>
               <a:spcAft>
-                <a:spcPts val="600"/>
+                <a:spcPts val="700"/>
               </a:spcAft>
             </a:pPr>
             <a:r>
@@ -6697,7 +5347,7 @@
                 <a:spcPct val="105000"/>
               </a:lnSpc>
               <a:spcAft>
-                <a:spcPts val="600"/>
+                <a:spcPts val="700"/>
               </a:spcAft>
             </a:pPr>
             <a:r>

</xml_diff>